<commit_message>
Mejorar el diseño y la estructura de los dashboards y la lista de tareas, ajustando márgenes y espacios para una mejor presentación. Actualizar el manual de uso con información de acceso y enlaces relevantes.
</commit_message>
<xml_diff>
--- a/docs/Agrogestion_TFG_DAW.pptx
+++ b/docs/Agrogestion_TFG_DAW.pptx
@@ -5,7 +5,7 @@
     <p:sldMasterId id="2147483648" r:id="rId1"/>
   </p:sldMasterIdLst>
   <p:notesMasterIdLst>
-    <p:notesMasterId r:id="rId20"/>
+    <p:notesMasterId r:id="rId18"/>
   </p:notesMasterIdLst>
   <p:sldIdLst>
     <p:sldId id="256" r:id="rId2"/>
@@ -21,11 +21,9 @@
     <p:sldId id="266" r:id="rId12"/>
     <p:sldId id="267" r:id="rId13"/>
     <p:sldId id="268" r:id="rId14"/>
-    <p:sldId id="269" r:id="rId15"/>
-    <p:sldId id="270" r:id="rId16"/>
-    <p:sldId id="271" r:id="rId17"/>
-    <p:sldId id="272" r:id="rId18"/>
-    <p:sldId id="273" r:id="rId19"/>
+    <p:sldId id="271" r:id="rId15"/>
+    <p:sldId id="272" r:id="rId16"/>
+    <p:sldId id="273" r:id="rId17"/>
   </p:sldIdLst>
   <p:sldSz cx="9144000" cy="5143500" type="screen16x9"/>
   <p:notesSz cx="5143500" cy="9144000"/>
@@ -926,174 +924,6 @@
 </p:notes>
 </file>
 
-<file path=ppt/notesSlides/notesSlide17.xml><?xml version="1.0" encoding="utf-8"?>
-<p:notes xmlns:a="http://schemas.openxmlformats.org/drawingml/2006/main" xmlns:r="http://schemas.openxmlformats.org/officeDocument/2006/relationships" xmlns:p="http://schemas.openxmlformats.org/presentationml/2006/main">
-  <p:cSld>
-    <p:spTree>
-      <p:nvGrpSpPr>
-        <p:cNvPr id="1" name=""/>
-        <p:cNvGrpSpPr/>
-        <p:nvPr/>
-      </p:nvGrpSpPr>
-      <p:grpSpPr>
-        <a:xfrm>
-          <a:off x="0" y="0"/>
-          <a:ext cx="0" cy="0"/>
-          <a:chOff x="0" y="0"/>
-          <a:chExt cx="0" cy="0"/>
-        </a:xfrm>
-      </p:grpSpPr>
-      <p:sp>
-        <p:nvSpPr>
-          <p:cNvPr id="2" name="Slide Image Placeholder 1"/>
-          <p:cNvSpPr>
-            <a:spLocks noGrp="1" noRot="1" noChangeAspect="1"/>
-          </p:cNvSpPr>
-          <p:nvPr>
-            <p:ph type="sldImg"/>
-          </p:nvPr>
-        </p:nvSpPr>
-        <p:spPr/>
-      </p:sp>
-      <p:sp>
-        <p:nvSpPr>
-          <p:cNvPr id="3" name="Notes Placeholder 2"/>
-          <p:cNvSpPr>
-            <a:spLocks noGrp="1"/>
-          </p:cNvSpPr>
-          <p:nvPr>
-            <p:ph type="body" idx="1"/>
-          </p:nvPr>
-        </p:nvSpPr>
-        <p:spPr/>
-        <p:txBody>
-          <a:bodyPr/>
-          <a:lstStyle/>
-          <a:p>
-            <a:endParaRPr lang="en-US" dirty="0"/>
-          </a:p>
-        </p:txBody>
-      </p:sp>
-      <p:sp>
-        <p:nvSpPr>
-          <p:cNvPr id="4" name="Slide Number Placeholder 3"/>
-          <p:cNvSpPr>
-            <a:spLocks noGrp="1"/>
-          </p:cNvSpPr>
-          <p:nvPr>
-            <p:ph type="sldNum" sz="quarter" idx="10"/>
-          </p:nvPr>
-        </p:nvSpPr>
-        <p:spPr/>
-        <p:txBody>
-          <a:bodyPr/>
-          <a:lstStyle/>
-          <a:p>
-            <a:fld id="{F7021451-1387-4CA6-816F-3879F97B5CBC}" type="slidenum">
-              <a:rPr lang="en-US"/>
-              <a:t>17</a:t>
-            </a:fld>
-            <a:endParaRPr lang="en-US" dirty="0"/>
-          </a:p>
-        </p:txBody>
-      </p:sp>
-    </p:spTree>
-    <p:extLst>
-      <p:ext uri="{BB962C8B-B14F-4D97-AF65-F5344CB8AC3E}">
-        <p14:creationId xmlns:p14="http://schemas.microsoft.com/office/powerpoint/2010/main" val="1024086991"/>
-      </p:ext>
-    </p:extLst>
-  </p:cSld>
-  <p:clrMapOvr>
-    <a:masterClrMapping/>
-  </p:clrMapOvr>
-</p:notes>
-</file>
-
-<file path=ppt/notesSlides/notesSlide18.xml><?xml version="1.0" encoding="utf-8"?>
-<p:notes xmlns:a="http://schemas.openxmlformats.org/drawingml/2006/main" xmlns:r="http://schemas.openxmlformats.org/officeDocument/2006/relationships" xmlns:p="http://schemas.openxmlformats.org/presentationml/2006/main">
-  <p:cSld>
-    <p:spTree>
-      <p:nvGrpSpPr>
-        <p:cNvPr id="1" name=""/>
-        <p:cNvGrpSpPr/>
-        <p:nvPr/>
-      </p:nvGrpSpPr>
-      <p:grpSpPr>
-        <a:xfrm>
-          <a:off x="0" y="0"/>
-          <a:ext cx="0" cy="0"/>
-          <a:chOff x="0" y="0"/>
-          <a:chExt cx="0" cy="0"/>
-        </a:xfrm>
-      </p:grpSpPr>
-      <p:sp>
-        <p:nvSpPr>
-          <p:cNvPr id="2" name="Slide Image Placeholder 1"/>
-          <p:cNvSpPr>
-            <a:spLocks noGrp="1" noRot="1" noChangeAspect="1"/>
-          </p:cNvSpPr>
-          <p:nvPr>
-            <p:ph type="sldImg"/>
-          </p:nvPr>
-        </p:nvSpPr>
-        <p:spPr/>
-      </p:sp>
-      <p:sp>
-        <p:nvSpPr>
-          <p:cNvPr id="3" name="Notes Placeholder 2"/>
-          <p:cNvSpPr>
-            <a:spLocks noGrp="1"/>
-          </p:cNvSpPr>
-          <p:nvPr>
-            <p:ph type="body" idx="1"/>
-          </p:nvPr>
-        </p:nvSpPr>
-        <p:spPr/>
-        <p:txBody>
-          <a:bodyPr/>
-          <a:lstStyle/>
-          <a:p>
-            <a:endParaRPr lang="en-US" dirty="0"/>
-          </a:p>
-        </p:txBody>
-      </p:sp>
-      <p:sp>
-        <p:nvSpPr>
-          <p:cNvPr id="4" name="Slide Number Placeholder 3"/>
-          <p:cNvSpPr>
-            <a:spLocks noGrp="1"/>
-          </p:cNvSpPr>
-          <p:nvPr>
-            <p:ph type="sldNum" sz="quarter" idx="10"/>
-          </p:nvPr>
-        </p:nvSpPr>
-        <p:spPr/>
-        <p:txBody>
-          <a:bodyPr/>
-          <a:lstStyle/>
-          <a:p>
-            <a:fld id="{F7021451-1387-4CA6-816F-3879F97B5CBC}" type="slidenum">
-              <a:rPr lang="en-US"/>
-              <a:t>18</a:t>
-            </a:fld>
-            <a:endParaRPr lang="en-US" dirty="0"/>
-          </a:p>
-        </p:txBody>
-      </p:sp>
-    </p:spTree>
-    <p:extLst>
-      <p:ext uri="{BB962C8B-B14F-4D97-AF65-F5344CB8AC3E}">
-        <p14:creationId xmlns:p14="http://schemas.microsoft.com/office/powerpoint/2010/main" val="1024086991"/>
-      </p:ext>
-    </p:extLst>
-  </p:cSld>
-  <p:clrMapOvr>
-    <a:masterClrMapping/>
-  </p:clrMapOvr>
-</p:notes>
-</file>
-
 <file path=ppt/notesSlides/notesSlide2.xml><?xml version="1.0" encoding="utf-8"?>
 <p:notes xmlns:a="http://schemas.openxmlformats.org/drawingml/2006/main" xmlns:r="http://schemas.openxmlformats.org/officeDocument/2006/relationships" xmlns:p="http://schemas.openxmlformats.org/presentationml/2006/main">
   <p:cSld>
@@ -2739,7 +2569,7 @@
                 <a:ea typeface="Calibri" pitchFamily="34" charset="-122"/>
                 <a:cs typeface="Calibri" pitchFamily="34" charset="-120"/>
               </a:rPr>
-              <a:t>10 / 18</a:t>
+              <a:t>10 / 16</a:t>
             </a:r>
             <a:endParaRPr lang="en-US" sz="900" dirty="0"/>
           </a:p>
@@ -3944,7 +3774,7 @@
                 <a:ea typeface="Calibri" pitchFamily="34" charset="-122"/>
                 <a:cs typeface="Calibri" pitchFamily="34" charset="-120"/>
               </a:rPr>
-              <a:t>11 / 18</a:t>
+              <a:t>11 / 16</a:t>
             </a:r>
             <a:endParaRPr lang="en-US" sz="900" dirty="0"/>
           </a:p>
@@ -5241,7 +5071,7 @@
                 <a:ea typeface="Calibri" pitchFamily="34" charset="-122"/>
                 <a:cs typeface="Calibri" pitchFamily="34" charset="-120"/>
               </a:rPr>
-              <a:t>12 / 18</a:t>
+              <a:t>12 / 16</a:t>
             </a:r>
             <a:endParaRPr lang="en-US" sz="900" dirty="0"/>
           </a:p>
@@ -6282,7 +6112,7 @@
                 <a:ea typeface="Calibri" pitchFamily="34" charset="-122"/>
                 <a:cs typeface="Calibri" pitchFamily="34" charset="-120"/>
               </a:rPr>
-              <a:t>13 / 18</a:t>
+              <a:t>13 / 16</a:t>
             </a:r>
             <a:endParaRPr lang="en-US" sz="900" dirty="0"/>
           </a:p>
@@ -6825,2262 +6655,6 @@
 </file>
 
 <file path=ppt/slides/slide14.xml><?xml version="1.0" encoding="utf-8"?>
-<p:sld xmlns:a="http://schemas.openxmlformats.org/drawingml/2006/main" xmlns:r="http://schemas.openxmlformats.org/officeDocument/2006/relationships" xmlns:p="http://schemas.openxmlformats.org/presentationml/2006/main">
-  <p:cSld name="Slide 14">
-    <p:bg>
-      <p:bgPr>
-        <a:solidFill>
-          <a:srgbClr val="F9F6F0"/>
-        </a:solidFill>
-        <a:effectLst/>
-      </p:bgPr>
-    </p:bg>
-    <p:spTree>
-      <p:nvGrpSpPr>
-        <p:cNvPr id="1" name=""/>
-        <p:cNvGrpSpPr/>
-        <p:nvPr/>
-      </p:nvGrpSpPr>
-      <p:grpSpPr>
-        <a:xfrm>
-          <a:off x="0" y="0"/>
-          <a:ext cx="0" cy="0"/>
-          <a:chOff x="0" y="0"/>
-          <a:chExt cx="0" cy="0"/>
-        </a:xfrm>
-      </p:grpSpPr>
-      <p:sp>
-        <p:nvSpPr>
-          <p:cNvPr id="2" name="Shape 0"/>
-          <p:cNvSpPr/>
-          <p:nvPr/>
-        </p:nvSpPr>
-        <p:spPr>
-          <a:xfrm>
-            <a:off x="365760" y="228600"/>
-            <a:ext cx="64008" cy="502920"/>
-          </a:xfrm>
-          <a:prstGeom prst="rect">
-            <a:avLst/>
-          </a:prstGeom>
-          <a:solidFill>
-            <a:srgbClr val="D4A017"/>
-          </a:solidFill>
-          <a:ln/>
-        </p:spPr>
-      </p:sp>
-      <p:sp>
-        <p:nvSpPr>
-          <p:cNvPr id="3" name="Text 1"/>
-          <p:cNvSpPr/>
-          <p:nvPr/>
-        </p:nvSpPr>
-        <p:spPr>
-          <a:xfrm>
-            <a:off x="530352" y="201168"/>
-            <a:ext cx="8229600" cy="347472"/>
-          </a:xfrm>
-          <a:prstGeom prst="rect">
-            <a:avLst/>
-          </a:prstGeom>
-          <a:noFill/>
-          <a:ln/>
-        </p:spPr>
-        <p:txBody>
-          <a:bodyPr wrap="square" lIns="0" tIns="0" rIns="0" bIns="0" rtlCol="0" anchor="ctr"/>
-          <a:lstStyle/>
-          <a:p>
-            <a:pPr marL="0" indent="0">
-              <a:buNone/>
-            </a:pPr>
-            <a:r>
-              <a:rPr lang="en-US" sz="2200" b="1" dirty="0">
-                <a:solidFill>
-                  <a:srgbClr val="1B5E20"/>
-                </a:solidFill>
-                <a:latin typeface="Calibri" pitchFamily="34" charset="0"/>
-                <a:ea typeface="Calibri" pitchFamily="34" charset="-122"/>
-                <a:cs typeface="Calibri" pitchFamily="34" charset="-120"/>
-              </a:rPr>
-              <a:t>Metodología y Planificación</a:t>
-            </a:r>
-            <a:endParaRPr lang="en-US" sz="2200" dirty="0"/>
-          </a:p>
-        </p:txBody>
-      </p:sp>
-      <p:sp>
-        <p:nvSpPr>
-          <p:cNvPr id="4" name="Text 2"/>
-          <p:cNvSpPr/>
-          <p:nvPr/>
-        </p:nvSpPr>
-        <p:spPr>
-          <a:xfrm>
-            <a:off x="530352" y="566928"/>
-            <a:ext cx="7772400" cy="256032"/>
-          </a:xfrm>
-          <a:prstGeom prst="rect">
-            <a:avLst/>
-          </a:prstGeom>
-          <a:noFill/>
-          <a:ln/>
-        </p:spPr>
-        <p:txBody>
-          <a:bodyPr wrap="square" lIns="0" tIns="0" rIns="0" bIns="0" rtlCol="0" anchor="ctr"/>
-          <a:lstStyle/>
-          <a:p>
-            <a:pPr marL="0" indent="0">
-              <a:buNone/>
-            </a:pPr>
-            <a:r>
-              <a:rPr lang="en-US" sz="1200" i="1" dirty="0">
-                <a:solidFill>
-                  <a:srgbClr val="5A5A5A"/>
-                </a:solidFill>
-                <a:latin typeface="Calibri" pitchFamily="34" charset="0"/>
-                <a:ea typeface="Calibri" pitchFamily="34" charset="-122"/>
-                <a:cs typeface="Calibri" pitchFamily="34" charset="-120"/>
-              </a:rPr>
-              <a:t>Desarrollo iterativo e incremental — 2 trimestres</a:t>
-            </a:r>
-            <a:endParaRPr lang="en-US" sz="1200" dirty="0"/>
-          </a:p>
-        </p:txBody>
-      </p:sp>
-      <p:sp>
-        <p:nvSpPr>
-          <p:cNvPr id="5" name="Text 3"/>
-          <p:cNvSpPr/>
-          <p:nvPr/>
-        </p:nvSpPr>
-        <p:spPr>
-          <a:xfrm>
-            <a:off x="8046720" y="4754880"/>
-            <a:ext cx="914400" cy="274320"/>
-          </a:xfrm>
-          <a:prstGeom prst="rect">
-            <a:avLst/>
-          </a:prstGeom>
-          <a:noFill/>
-          <a:ln/>
-        </p:spPr>
-        <p:txBody>
-          <a:bodyPr wrap="square" rtlCol="0" anchor="ctr"/>
-          <a:lstStyle/>
-          <a:p>
-            <a:pPr marL="0" indent="0" algn="r">
-              <a:buNone/>
-            </a:pPr>
-            <a:r>
-              <a:rPr lang="en-US" sz="900" dirty="0">
-                <a:solidFill>
-                  <a:srgbClr val="999999"/>
-                </a:solidFill>
-                <a:latin typeface="Calibri" pitchFamily="34" charset="0"/>
-                <a:ea typeface="Calibri" pitchFamily="34" charset="-122"/>
-                <a:cs typeface="Calibri" pitchFamily="34" charset="-120"/>
-              </a:rPr>
-              <a:t>14 / 18</a:t>
-            </a:r>
-            <a:endParaRPr lang="en-US" sz="900" dirty="0"/>
-          </a:p>
-        </p:txBody>
-      </p:sp>
-      <p:sp>
-        <p:nvSpPr>
-          <p:cNvPr id="6" name="Shape 4"/>
-          <p:cNvSpPr/>
-          <p:nvPr/>
-        </p:nvSpPr>
-        <p:spPr>
-          <a:xfrm>
-            <a:off x="457200" y="1463040"/>
-            <a:ext cx="8229600" cy="54864"/>
-          </a:xfrm>
-          <a:prstGeom prst="rect">
-            <a:avLst/>
-          </a:prstGeom>
-          <a:solidFill>
-            <a:srgbClr val="2E7D32"/>
-          </a:solidFill>
-          <a:ln/>
-        </p:spPr>
-      </p:sp>
-      <p:sp>
-        <p:nvSpPr>
-          <p:cNvPr id="7" name="Shape 5"/>
-          <p:cNvSpPr/>
-          <p:nvPr/>
-        </p:nvSpPr>
-        <p:spPr>
-          <a:xfrm>
-            <a:off x="2377440" y="1325880"/>
-            <a:ext cx="292608" cy="292608"/>
-          </a:xfrm>
-          <a:prstGeom prst="line">
-            <a:avLst/>
-          </a:prstGeom>
-          <a:solidFill>
-            <a:srgbClr val="D4A017"/>
-          </a:solidFill>
-          <a:ln/>
-        </p:spPr>
-      </p:sp>
-      <p:sp>
-        <p:nvSpPr>
-          <p:cNvPr id="8" name="Shape 6"/>
-          <p:cNvSpPr/>
-          <p:nvPr/>
-        </p:nvSpPr>
-        <p:spPr>
-          <a:xfrm>
-            <a:off x="457200" y="1627632"/>
-            <a:ext cx="4114800" cy="2651760"/>
-          </a:xfrm>
-          <a:prstGeom prst="rect">
-            <a:avLst/>
-          </a:prstGeom>
-          <a:solidFill>
-            <a:srgbClr val="FFFFFF"/>
-          </a:solidFill>
-          <a:ln/>
-          <a:effectLst>
-            <a:outerShdw blurRad="101600" dist="38100" dir="8100000" algn="bl" rotWithShape="0">
-              <a:srgbClr val="000000">
-                <a:alpha val="18000"/>
-              </a:srgbClr>
-            </a:outerShdw>
-          </a:effectLst>
-        </p:spPr>
-      </p:sp>
-      <p:sp>
-        <p:nvSpPr>
-          <p:cNvPr id="9" name="Shape 7"/>
-          <p:cNvSpPr/>
-          <p:nvPr/>
-        </p:nvSpPr>
-        <p:spPr>
-          <a:xfrm>
-            <a:off x="457200" y="1627632"/>
-            <a:ext cx="4114800" cy="502920"/>
-          </a:xfrm>
-          <a:prstGeom prst="rect">
-            <a:avLst/>
-          </a:prstGeom>
-          <a:solidFill>
-            <a:srgbClr val="5D4037"/>
-          </a:solidFill>
-          <a:ln/>
-        </p:spPr>
-      </p:sp>
-      <p:sp>
-        <p:nvSpPr>
-          <p:cNvPr id="10" name="Text 8"/>
-          <p:cNvSpPr/>
-          <p:nvPr/>
-        </p:nvSpPr>
-        <p:spPr>
-          <a:xfrm>
-            <a:off x="457200" y="1627632"/>
-            <a:ext cx="4114800" cy="502920"/>
-          </a:xfrm>
-          <a:prstGeom prst="rect">
-            <a:avLst/>
-          </a:prstGeom>
-          <a:noFill/>
-          <a:ln/>
-        </p:spPr>
-        <p:txBody>
-          <a:bodyPr wrap="square" rtlCol="0" anchor="ctr"/>
-          <a:lstStyle/>
-          <a:p>
-            <a:pPr marL="0" indent="0" algn="ctr">
-              <a:buNone/>
-            </a:pPr>
-            <a:r>
-              <a:rPr lang="en-US" sz="1300" b="1" dirty="0">
-                <a:solidFill>
-                  <a:srgbClr val="FFFFFF"/>
-                </a:solidFill>
-                <a:latin typeface="Calibri" pitchFamily="34" charset="0"/>
-                <a:ea typeface="Calibri" pitchFamily="34" charset="-122"/>
-                <a:cs typeface="Calibri" pitchFamily="34" charset="-120"/>
-              </a:rPr>
-              <a:t>1er Trimestre</a:t>
-            </a:r>
-            <a:endParaRPr lang="en-US" sz="1300" dirty="0"/>
-          </a:p>
-          <a:p>
-            <a:pPr marL="0" indent="0" algn="ctr">
-              <a:buNone/>
-            </a:pPr>
-            <a:r>
-              <a:rPr lang="en-US" sz="1300" b="1">
-                <a:solidFill>
-                  <a:srgbClr val="FFFFFF"/>
-                </a:solidFill>
-                <a:latin typeface="Calibri" pitchFamily="34" charset="0"/>
-                <a:ea typeface="Calibri" pitchFamily="34" charset="-122"/>
-                <a:cs typeface="Calibri" pitchFamily="34" charset="-120"/>
-              </a:rPr>
-              <a:t>2025/2026</a:t>
-            </a:r>
-            <a:endParaRPr lang="en-US" sz="1300" dirty="0"/>
-          </a:p>
-        </p:txBody>
-      </p:sp>
-      <p:sp>
-        <p:nvSpPr>
-          <p:cNvPr id="11" name="Text 9"/>
-          <p:cNvSpPr/>
-          <p:nvPr/>
-        </p:nvSpPr>
-        <p:spPr>
-          <a:xfrm>
-            <a:off x="594360" y="2194560"/>
-            <a:ext cx="3840480" cy="347472"/>
-          </a:xfrm>
-          <a:prstGeom prst="rect">
-            <a:avLst/>
-          </a:prstGeom>
-          <a:noFill/>
-          <a:ln/>
-        </p:spPr>
-        <p:txBody>
-          <a:bodyPr wrap="square" rtlCol="0" anchor="ctr"/>
-          <a:lstStyle/>
-          <a:p>
-            <a:pPr marL="0" indent="0">
-              <a:buNone/>
-            </a:pPr>
-            <a:r>
-              <a:rPr lang="en-US" sz="1200" dirty="0">
-                <a:solidFill>
-                  <a:srgbClr val="1A1A1A"/>
-                </a:solidFill>
-                <a:latin typeface="Calibri" pitchFamily="34" charset="0"/>
-                <a:ea typeface="Calibri" pitchFamily="34" charset="-122"/>
-                <a:cs typeface="Calibri" pitchFamily="34" charset="-120"/>
-              </a:rPr>
-              <a:t>✔ Análisis de viabilidad</a:t>
-            </a:r>
-            <a:endParaRPr lang="en-US" sz="1200" dirty="0"/>
-          </a:p>
-        </p:txBody>
-      </p:sp>
-      <p:sp>
-        <p:nvSpPr>
-          <p:cNvPr id="12" name="Text 10"/>
-          <p:cNvSpPr/>
-          <p:nvPr/>
-        </p:nvSpPr>
-        <p:spPr>
-          <a:xfrm>
-            <a:off x="594360" y="2587752"/>
-            <a:ext cx="3840480" cy="347472"/>
-          </a:xfrm>
-          <a:prstGeom prst="rect">
-            <a:avLst/>
-          </a:prstGeom>
-          <a:noFill/>
-          <a:ln/>
-        </p:spPr>
-        <p:txBody>
-          <a:bodyPr wrap="square" rtlCol="0" anchor="ctr"/>
-          <a:lstStyle/>
-          <a:p>
-            <a:pPr marL="0" indent="0">
-              <a:buNone/>
-            </a:pPr>
-            <a:r>
-              <a:rPr lang="en-US" sz="1200" dirty="0">
-                <a:solidFill>
-                  <a:srgbClr val="1A1A1A"/>
-                </a:solidFill>
-                <a:latin typeface="Calibri" pitchFamily="34" charset="0"/>
-                <a:ea typeface="Calibri" pitchFamily="34" charset="-122"/>
-                <a:cs typeface="Calibri" pitchFamily="34" charset="-120"/>
-              </a:rPr>
-              <a:t>✔ Requisitos y diseño</a:t>
-            </a:r>
-            <a:endParaRPr lang="en-US" sz="1200" dirty="0"/>
-          </a:p>
-        </p:txBody>
-      </p:sp>
-      <p:sp>
-        <p:nvSpPr>
-          <p:cNvPr id="13" name="Text 11"/>
-          <p:cNvSpPr/>
-          <p:nvPr/>
-        </p:nvSpPr>
-        <p:spPr>
-          <a:xfrm>
-            <a:off x="594360" y="2980944"/>
-            <a:ext cx="3840480" cy="347472"/>
-          </a:xfrm>
-          <a:prstGeom prst="rect">
-            <a:avLst/>
-          </a:prstGeom>
-          <a:noFill/>
-          <a:ln/>
-        </p:spPr>
-        <p:txBody>
-          <a:bodyPr wrap="square" rtlCol="0" anchor="ctr"/>
-          <a:lstStyle/>
-          <a:p>
-            <a:pPr marL="0" indent="0">
-              <a:buNone/>
-            </a:pPr>
-            <a:r>
-              <a:rPr lang="en-US" sz="1200" dirty="0">
-                <a:solidFill>
-                  <a:srgbClr val="1A1A1A"/>
-                </a:solidFill>
-                <a:latin typeface="Calibri" pitchFamily="34" charset="0"/>
-                <a:ea typeface="Calibri" pitchFamily="34" charset="-122"/>
-                <a:cs typeface="Calibri" pitchFamily="34" charset="-120"/>
-              </a:rPr>
-              <a:t>✔ Modelo de datos</a:t>
-            </a:r>
-            <a:endParaRPr lang="en-US" sz="1200" dirty="0"/>
-          </a:p>
-        </p:txBody>
-      </p:sp>
-      <p:sp>
-        <p:nvSpPr>
-          <p:cNvPr id="14" name="Text 12"/>
-          <p:cNvSpPr/>
-          <p:nvPr/>
-        </p:nvSpPr>
-        <p:spPr>
-          <a:xfrm>
-            <a:off x="594360" y="3374136"/>
-            <a:ext cx="3840480" cy="347472"/>
-          </a:xfrm>
-          <a:prstGeom prst="rect">
-            <a:avLst/>
-          </a:prstGeom>
-          <a:noFill/>
-          <a:ln/>
-        </p:spPr>
-        <p:txBody>
-          <a:bodyPr wrap="square" rtlCol="0" anchor="ctr"/>
-          <a:lstStyle/>
-          <a:p>
-            <a:pPr marL="0" indent="0">
-              <a:buNone/>
-            </a:pPr>
-            <a:r>
-              <a:rPr lang="en-US" sz="1200" dirty="0">
-                <a:solidFill>
-                  <a:srgbClr val="1A1A1A"/>
-                </a:solidFill>
-                <a:latin typeface="Calibri" pitchFamily="34" charset="0"/>
-                <a:ea typeface="Calibri" pitchFamily="34" charset="-122"/>
-                <a:cs typeface="Calibri" pitchFamily="34" charset="-120"/>
-              </a:rPr>
-              <a:t>✔ Arquitectura</a:t>
-            </a:r>
-            <a:endParaRPr lang="en-US" sz="1200" dirty="0"/>
-          </a:p>
-        </p:txBody>
-      </p:sp>
-      <p:sp>
-        <p:nvSpPr>
-          <p:cNvPr id="15" name="Text 13"/>
-          <p:cNvSpPr/>
-          <p:nvPr/>
-        </p:nvSpPr>
-        <p:spPr>
-          <a:xfrm>
-            <a:off x="594360" y="3767328"/>
-            <a:ext cx="3840480" cy="347472"/>
-          </a:xfrm>
-          <a:prstGeom prst="rect">
-            <a:avLst/>
-          </a:prstGeom>
-          <a:noFill/>
-          <a:ln/>
-        </p:spPr>
-        <p:txBody>
-          <a:bodyPr wrap="square" rtlCol="0" anchor="ctr"/>
-          <a:lstStyle/>
-          <a:p>
-            <a:pPr marL="0" indent="0">
-              <a:buNone/>
-            </a:pPr>
-            <a:r>
-              <a:rPr lang="en-US" sz="1200" dirty="0">
-                <a:solidFill>
-                  <a:srgbClr val="1A1A1A"/>
-                </a:solidFill>
-                <a:latin typeface="Calibri" pitchFamily="34" charset="0"/>
-                <a:ea typeface="Calibri" pitchFamily="34" charset="-122"/>
-                <a:cs typeface="Calibri" pitchFamily="34" charset="-120"/>
-              </a:rPr>
-              <a:t>✔ Mockups + Tecnologías</a:t>
-            </a:r>
-            <a:endParaRPr lang="en-US" sz="1200" dirty="0"/>
-          </a:p>
-        </p:txBody>
-      </p:sp>
-      <p:sp>
-        <p:nvSpPr>
-          <p:cNvPr id="16" name="Shape 14"/>
-          <p:cNvSpPr/>
-          <p:nvPr/>
-        </p:nvSpPr>
-        <p:spPr>
-          <a:xfrm>
-            <a:off x="6583680" y="1325880"/>
-            <a:ext cx="292608" cy="292608"/>
-          </a:xfrm>
-          <a:prstGeom prst="line">
-            <a:avLst/>
-          </a:prstGeom>
-          <a:solidFill>
-            <a:srgbClr val="D4A017"/>
-          </a:solidFill>
-          <a:ln/>
-        </p:spPr>
-      </p:sp>
-      <p:sp>
-        <p:nvSpPr>
-          <p:cNvPr id="17" name="Shape 15"/>
-          <p:cNvSpPr/>
-          <p:nvPr/>
-        </p:nvSpPr>
-        <p:spPr>
-          <a:xfrm>
-            <a:off x="4663440" y="1627632"/>
-            <a:ext cx="4114800" cy="2651760"/>
-          </a:xfrm>
-          <a:prstGeom prst="rect">
-            <a:avLst/>
-          </a:prstGeom>
-          <a:solidFill>
-            <a:srgbClr val="FFFFFF"/>
-          </a:solidFill>
-          <a:ln/>
-          <a:effectLst>
-            <a:outerShdw blurRad="101600" dist="38100" dir="8100000" algn="bl" rotWithShape="0">
-              <a:srgbClr val="000000">
-                <a:alpha val="18000"/>
-              </a:srgbClr>
-            </a:outerShdw>
-          </a:effectLst>
-        </p:spPr>
-      </p:sp>
-      <p:sp>
-        <p:nvSpPr>
-          <p:cNvPr id="18" name="Shape 16"/>
-          <p:cNvSpPr/>
-          <p:nvPr/>
-        </p:nvSpPr>
-        <p:spPr>
-          <a:xfrm>
-            <a:off x="4663440" y="1627632"/>
-            <a:ext cx="4114800" cy="502920"/>
-          </a:xfrm>
-          <a:prstGeom prst="rect">
-            <a:avLst/>
-          </a:prstGeom>
-          <a:solidFill>
-            <a:srgbClr val="1B5E20"/>
-          </a:solidFill>
-          <a:ln/>
-        </p:spPr>
-      </p:sp>
-      <p:sp>
-        <p:nvSpPr>
-          <p:cNvPr id="19" name="Text 17"/>
-          <p:cNvSpPr/>
-          <p:nvPr/>
-        </p:nvSpPr>
-        <p:spPr>
-          <a:xfrm>
-            <a:off x="4663440" y="1627632"/>
-            <a:ext cx="4114800" cy="502920"/>
-          </a:xfrm>
-          <a:prstGeom prst="rect">
-            <a:avLst/>
-          </a:prstGeom>
-          <a:noFill/>
-          <a:ln/>
-        </p:spPr>
-        <p:txBody>
-          <a:bodyPr wrap="square" rtlCol="0" anchor="ctr"/>
-          <a:lstStyle/>
-          <a:p>
-            <a:pPr marL="0" indent="0" algn="ctr">
-              <a:buNone/>
-            </a:pPr>
-            <a:r>
-              <a:rPr lang="en-US" sz="1300" b="1" dirty="0">
-                <a:solidFill>
-                  <a:srgbClr val="FFFFFF"/>
-                </a:solidFill>
-                <a:latin typeface="Calibri" pitchFamily="34" charset="0"/>
-                <a:ea typeface="Calibri" pitchFamily="34" charset="-122"/>
-                <a:cs typeface="Calibri" pitchFamily="34" charset="-120"/>
-              </a:rPr>
-              <a:t>2do Trimestre</a:t>
-            </a:r>
-            <a:endParaRPr lang="en-US" sz="1300" dirty="0"/>
-          </a:p>
-          <a:p>
-            <a:pPr marL="0" indent="0" algn="ctr">
-              <a:buNone/>
-            </a:pPr>
-            <a:r>
-              <a:rPr lang="en-US" sz="1300" b="1" dirty="0">
-                <a:solidFill>
-                  <a:srgbClr val="FFFFFF"/>
-                </a:solidFill>
-                <a:latin typeface="Calibri" pitchFamily="34" charset="0"/>
-                <a:ea typeface="Calibri" pitchFamily="34" charset="-122"/>
-                <a:cs typeface="Calibri" pitchFamily="34" charset="-120"/>
-              </a:rPr>
-              <a:t>2025/2026</a:t>
-            </a:r>
-            <a:endParaRPr lang="en-US" sz="1300" dirty="0"/>
-          </a:p>
-        </p:txBody>
-      </p:sp>
-      <p:sp>
-        <p:nvSpPr>
-          <p:cNvPr id="20" name="Text 18"/>
-          <p:cNvSpPr/>
-          <p:nvPr/>
-        </p:nvSpPr>
-        <p:spPr>
-          <a:xfrm>
-            <a:off x="4800600" y="2194560"/>
-            <a:ext cx="3840480" cy="347472"/>
-          </a:xfrm>
-          <a:prstGeom prst="rect">
-            <a:avLst/>
-          </a:prstGeom>
-          <a:noFill/>
-          <a:ln/>
-        </p:spPr>
-        <p:txBody>
-          <a:bodyPr wrap="square" rtlCol="0" anchor="ctr"/>
-          <a:lstStyle/>
-          <a:p>
-            <a:pPr marL="0" indent="0">
-              <a:buNone/>
-            </a:pPr>
-            <a:r>
-              <a:rPr lang="en-US" sz="1200" dirty="0">
-                <a:solidFill>
-                  <a:srgbClr val="1A1A1A"/>
-                </a:solidFill>
-                <a:latin typeface="Calibri" pitchFamily="34" charset="0"/>
-                <a:ea typeface="Calibri" pitchFamily="34" charset="-122"/>
-                <a:cs typeface="Calibri" pitchFamily="34" charset="-120"/>
-              </a:rPr>
-              <a:t>✔ Frontend completo</a:t>
-            </a:r>
-            <a:endParaRPr lang="en-US" sz="1200" dirty="0"/>
-          </a:p>
-        </p:txBody>
-      </p:sp>
-      <p:sp>
-        <p:nvSpPr>
-          <p:cNvPr id="21" name="Text 19"/>
-          <p:cNvSpPr/>
-          <p:nvPr/>
-        </p:nvSpPr>
-        <p:spPr>
-          <a:xfrm>
-            <a:off x="4800600" y="2587752"/>
-            <a:ext cx="3840480" cy="347472"/>
-          </a:xfrm>
-          <a:prstGeom prst="rect">
-            <a:avLst/>
-          </a:prstGeom>
-          <a:noFill/>
-          <a:ln/>
-        </p:spPr>
-        <p:txBody>
-          <a:bodyPr wrap="square" rtlCol="0" anchor="ctr"/>
-          <a:lstStyle/>
-          <a:p>
-            <a:pPr marL="0" indent="0">
-              <a:buNone/>
-            </a:pPr>
-            <a:r>
-              <a:rPr lang="en-US" sz="1200" dirty="0">
-                <a:solidFill>
-                  <a:srgbClr val="1A1A1A"/>
-                </a:solidFill>
-                <a:latin typeface="Calibri" pitchFamily="34" charset="0"/>
-                <a:ea typeface="Calibri" pitchFamily="34" charset="-122"/>
-                <a:cs typeface="Calibri" pitchFamily="34" charset="-120"/>
-              </a:rPr>
-              <a:t>✔ Auth + Roles + RLS</a:t>
-            </a:r>
-            <a:endParaRPr lang="en-US" sz="1200" dirty="0"/>
-          </a:p>
-        </p:txBody>
-      </p:sp>
-      <p:sp>
-        <p:nvSpPr>
-          <p:cNvPr id="22" name="Text 20"/>
-          <p:cNvSpPr/>
-          <p:nvPr/>
-        </p:nvSpPr>
-        <p:spPr>
-          <a:xfrm>
-            <a:off x="4800600" y="2980944"/>
-            <a:ext cx="3840480" cy="347472"/>
-          </a:xfrm>
-          <a:prstGeom prst="rect">
-            <a:avLst/>
-          </a:prstGeom>
-          <a:noFill/>
-          <a:ln/>
-        </p:spPr>
-        <p:txBody>
-          <a:bodyPr wrap="square" rtlCol="0" anchor="ctr"/>
-          <a:lstStyle/>
-          <a:p>
-            <a:pPr marL="0" indent="0">
-              <a:buNone/>
-            </a:pPr>
-            <a:r>
-              <a:rPr lang="en-US" sz="1200" dirty="0">
-                <a:solidFill>
-                  <a:srgbClr val="1A1A1A"/>
-                </a:solidFill>
-                <a:latin typeface="Calibri" pitchFamily="34" charset="0"/>
-                <a:ea typeface="Calibri" pitchFamily="34" charset="-122"/>
-                <a:cs typeface="Calibri" pitchFamily="34" charset="-120"/>
-              </a:rPr>
-              <a:t>✔ Terrenos + Tareas</a:t>
-            </a:r>
-            <a:endParaRPr lang="en-US" sz="1200" dirty="0"/>
-          </a:p>
-        </p:txBody>
-      </p:sp>
-      <p:sp>
-        <p:nvSpPr>
-          <p:cNvPr id="23" name="Text 21"/>
-          <p:cNvSpPr/>
-          <p:nvPr/>
-        </p:nvSpPr>
-        <p:spPr>
-          <a:xfrm>
-            <a:off x="4800600" y="3374136"/>
-            <a:ext cx="3840480" cy="347472"/>
-          </a:xfrm>
-          <a:prstGeom prst="rect">
-            <a:avLst/>
-          </a:prstGeom>
-          <a:noFill/>
-          <a:ln/>
-        </p:spPr>
-        <p:txBody>
-          <a:bodyPr wrap="square" rtlCol="0" anchor="ctr"/>
-          <a:lstStyle/>
-          <a:p>
-            <a:pPr marL="0" indent="0">
-              <a:buNone/>
-            </a:pPr>
-            <a:r>
-              <a:rPr lang="en-US" sz="1200" dirty="0">
-                <a:solidFill>
-                  <a:srgbClr val="1A1A1A"/>
-                </a:solidFill>
-                <a:latin typeface="Calibri" pitchFamily="34" charset="0"/>
-                <a:ea typeface="Calibri" pitchFamily="34" charset="-122"/>
-                <a:cs typeface="Calibri" pitchFamily="34" charset="-120"/>
-              </a:rPr>
-              <a:t>✔ i18n + Notificaciones</a:t>
-            </a:r>
-            <a:endParaRPr lang="en-US" sz="1200" dirty="0"/>
-          </a:p>
-        </p:txBody>
-      </p:sp>
-      <p:sp>
-        <p:nvSpPr>
-          <p:cNvPr id="24" name="Text 22"/>
-          <p:cNvSpPr/>
-          <p:nvPr/>
-        </p:nvSpPr>
-        <p:spPr>
-          <a:xfrm>
-            <a:off x="4800600" y="3767328"/>
-            <a:ext cx="3840480" cy="347472"/>
-          </a:xfrm>
-          <a:prstGeom prst="rect">
-            <a:avLst/>
-          </a:prstGeom>
-          <a:noFill/>
-          <a:ln/>
-        </p:spPr>
-        <p:txBody>
-          <a:bodyPr wrap="square" rtlCol="0" anchor="ctr"/>
-          <a:lstStyle/>
-          <a:p>
-            <a:pPr marL="0" indent="0">
-              <a:buNone/>
-            </a:pPr>
-            <a:r>
-              <a:rPr lang="en-US" sz="1200" dirty="0">
-                <a:solidFill>
-                  <a:srgbClr val="1A1A1A"/>
-                </a:solidFill>
-                <a:latin typeface="Calibri" pitchFamily="34" charset="0"/>
-                <a:ea typeface="Calibri" pitchFamily="34" charset="-122"/>
-                <a:cs typeface="Calibri" pitchFamily="34" charset="-120"/>
-              </a:rPr>
-              <a:t>✔ Pruebas + Despliegue</a:t>
-            </a:r>
-            <a:endParaRPr lang="en-US" sz="1200" dirty="0"/>
-          </a:p>
-        </p:txBody>
-      </p:sp>
-      <p:sp>
-        <p:nvSpPr>
-          <p:cNvPr id="25" name="Shape 23"/>
-          <p:cNvSpPr/>
-          <p:nvPr/>
-        </p:nvSpPr>
-        <p:spPr>
-          <a:xfrm>
-            <a:off x="365760" y="4434840"/>
-            <a:ext cx="8412480" cy="475488"/>
-          </a:xfrm>
-          <a:prstGeom prst="rect">
-            <a:avLst/>
-          </a:prstGeom>
-          <a:solidFill>
-            <a:srgbClr val="1B5E20"/>
-          </a:solidFill>
-          <a:ln/>
-          <a:effectLst>
-            <a:outerShdw blurRad="63500" dist="25400" dir="8100000" algn="bl" rotWithShape="0">
-              <a:srgbClr val="000000">
-                <a:alpha val="10000"/>
-              </a:srgbClr>
-            </a:outerShdw>
-          </a:effectLst>
-        </p:spPr>
-      </p:sp>
-      <p:sp>
-        <p:nvSpPr>
-          <p:cNvPr id="26" name="Text 24"/>
-          <p:cNvSpPr/>
-          <p:nvPr/>
-        </p:nvSpPr>
-        <p:spPr>
-          <a:xfrm>
-            <a:off x="365760" y="4434840"/>
-            <a:ext cx="8412480" cy="475488"/>
-          </a:xfrm>
-          <a:prstGeom prst="rect">
-            <a:avLst/>
-          </a:prstGeom>
-          <a:noFill/>
-          <a:ln/>
-        </p:spPr>
-        <p:txBody>
-          <a:bodyPr wrap="square" rtlCol="0" anchor="ctr"/>
-          <a:lstStyle/>
-          <a:p>
-            <a:pPr marL="0" indent="0" algn="ctr">
-              <a:buNone/>
-            </a:pPr>
-            <a:r>
-              <a:rPr lang="en-US" sz="1300" b="1" dirty="0">
-                <a:solidFill>
-                  <a:srgbClr val="FFFFFF"/>
-                </a:solidFill>
-                <a:latin typeface="Calibri" pitchFamily="34" charset="0"/>
-                <a:ea typeface="Calibri" pitchFamily="34" charset="-122"/>
-                <a:cs typeface="Calibri" pitchFamily="34" charset="-120"/>
-              </a:rPr>
-              <a:t>✅  13 objetivos específicos — todos cumplidos al cierre del proyecto</a:t>
-            </a:r>
-            <a:endParaRPr lang="en-US" sz="1300" dirty="0"/>
-          </a:p>
-        </p:txBody>
-      </p:sp>
-    </p:spTree>
-  </p:cSld>
-  <p:clrMapOvr>
-    <a:masterClrMapping/>
-  </p:clrMapOvr>
-</p:sld>
-</file>
-
-<file path=ppt/slides/slide15.xml><?xml version="1.0" encoding="utf-8"?>
-<p:sld xmlns:a="http://schemas.openxmlformats.org/drawingml/2006/main" xmlns:r="http://schemas.openxmlformats.org/officeDocument/2006/relationships" xmlns:p="http://schemas.openxmlformats.org/presentationml/2006/main">
-  <p:cSld name="Slide 15">
-    <p:bg>
-      <p:bgPr>
-        <a:solidFill>
-          <a:srgbClr val="F9F6F0"/>
-        </a:solidFill>
-        <a:effectLst/>
-      </p:bgPr>
-    </p:bg>
-    <p:spTree>
-      <p:nvGrpSpPr>
-        <p:cNvPr id="1" name=""/>
-        <p:cNvGrpSpPr/>
-        <p:nvPr/>
-      </p:nvGrpSpPr>
-      <p:grpSpPr>
-        <a:xfrm>
-          <a:off x="0" y="0"/>
-          <a:ext cx="0" cy="0"/>
-          <a:chOff x="0" y="0"/>
-          <a:chExt cx="0" cy="0"/>
-        </a:xfrm>
-      </p:grpSpPr>
-      <p:sp>
-        <p:nvSpPr>
-          <p:cNvPr id="2" name="Shape 0"/>
-          <p:cNvSpPr/>
-          <p:nvPr/>
-        </p:nvSpPr>
-        <p:spPr>
-          <a:xfrm>
-            <a:off x="365760" y="228600"/>
-            <a:ext cx="64008" cy="502920"/>
-          </a:xfrm>
-          <a:prstGeom prst="rect">
-            <a:avLst/>
-          </a:prstGeom>
-          <a:solidFill>
-            <a:srgbClr val="D4A017"/>
-          </a:solidFill>
-          <a:ln/>
-        </p:spPr>
-      </p:sp>
-      <p:sp>
-        <p:nvSpPr>
-          <p:cNvPr id="3" name="Text 1"/>
-          <p:cNvSpPr/>
-          <p:nvPr/>
-        </p:nvSpPr>
-        <p:spPr>
-          <a:xfrm>
-            <a:off x="530352" y="201168"/>
-            <a:ext cx="8229600" cy="347472"/>
-          </a:xfrm>
-          <a:prstGeom prst="rect">
-            <a:avLst/>
-          </a:prstGeom>
-          <a:noFill/>
-          <a:ln/>
-        </p:spPr>
-        <p:txBody>
-          <a:bodyPr wrap="square" lIns="0" tIns="0" rIns="0" bIns="0" rtlCol="0" anchor="ctr"/>
-          <a:lstStyle/>
-          <a:p>
-            <a:pPr marL="0" indent="0">
-              <a:buNone/>
-            </a:pPr>
-            <a:r>
-              <a:rPr lang="en-US" sz="2200" b="1" dirty="0">
-                <a:solidFill>
-                  <a:srgbClr val="1B5E20"/>
-                </a:solidFill>
-                <a:latin typeface="Calibri" pitchFamily="34" charset="0"/>
-                <a:ea typeface="Calibri" pitchFamily="34" charset="-122"/>
-                <a:cs typeface="Calibri" pitchFamily="34" charset="-120"/>
-              </a:rPr>
-              <a:t>Documentación Generada</a:t>
-            </a:r>
-            <a:endParaRPr lang="en-US" sz="2200" dirty="0"/>
-          </a:p>
-        </p:txBody>
-      </p:sp>
-      <p:sp>
-        <p:nvSpPr>
-          <p:cNvPr id="4" name="Text 2"/>
-          <p:cNvSpPr/>
-          <p:nvPr/>
-        </p:nvSpPr>
-        <p:spPr>
-          <a:xfrm>
-            <a:off x="530352" y="566928"/>
-            <a:ext cx="7772400" cy="256032"/>
-          </a:xfrm>
-          <a:prstGeom prst="rect">
-            <a:avLst/>
-          </a:prstGeom>
-          <a:noFill/>
-          <a:ln/>
-        </p:spPr>
-        <p:txBody>
-          <a:bodyPr wrap="square" lIns="0" tIns="0" rIns="0" bIns="0" rtlCol="0" anchor="ctr"/>
-          <a:lstStyle/>
-          <a:p>
-            <a:pPr marL="0" indent="0">
-              <a:buNone/>
-            </a:pPr>
-            <a:r>
-              <a:rPr lang="en-US" sz="1200" i="1" dirty="0">
-                <a:solidFill>
-                  <a:srgbClr val="5A5A5A"/>
-                </a:solidFill>
-                <a:latin typeface="Calibri" pitchFamily="34" charset="0"/>
-                <a:ea typeface="Calibri" pitchFamily="34" charset="-122"/>
-                <a:cs typeface="Calibri" pitchFamily="34" charset="-120"/>
-              </a:rPr>
-              <a:t>4 manuales + 3 diagramas técnicos</a:t>
-            </a:r>
-            <a:endParaRPr lang="en-US" sz="1200" dirty="0"/>
-          </a:p>
-        </p:txBody>
-      </p:sp>
-      <p:sp>
-        <p:nvSpPr>
-          <p:cNvPr id="5" name="Text 3"/>
-          <p:cNvSpPr/>
-          <p:nvPr/>
-        </p:nvSpPr>
-        <p:spPr>
-          <a:xfrm>
-            <a:off x="8046720" y="4754880"/>
-            <a:ext cx="914400" cy="274320"/>
-          </a:xfrm>
-          <a:prstGeom prst="rect">
-            <a:avLst/>
-          </a:prstGeom>
-          <a:noFill/>
-          <a:ln/>
-        </p:spPr>
-        <p:txBody>
-          <a:bodyPr wrap="square" rtlCol="0" anchor="ctr"/>
-          <a:lstStyle/>
-          <a:p>
-            <a:pPr marL="0" indent="0" algn="r">
-              <a:buNone/>
-            </a:pPr>
-            <a:r>
-              <a:rPr lang="en-US" sz="900" dirty="0">
-                <a:solidFill>
-                  <a:srgbClr val="999999"/>
-                </a:solidFill>
-                <a:latin typeface="Calibri" pitchFamily="34" charset="0"/>
-                <a:ea typeface="Calibri" pitchFamily="34" charset="-122"/>
-                <a:cs typeface="Calibri" pitchFamily="34" charset="-120"/>
-              </a:rPr>
-              <a:t>15 / 18</a:t>
-            </a:r>
-            <a:endParaRPr lang="en-US" sz="900" dirty="0"/>
-          </a:p>
-        </p:txBody>
-      </p:sp>
-      <p:sp>
-        <p:nvSpPr>
-          <p:cNvPr id="6" name="Shape 4"/>
-          <p:cNvSpPr/>
-          <p:nvPr/>
-        </p:nvSpPr>
-        <p:spPr>
-          <a:xfrm>
-            <a:off x="320040" y="960120"/>
-            <a:ext cx="2011680" cy="2286000"/>
-          </a:xfrm>
-          <a:prstGeom prst="rect">
-            <a:avLst/>
-          </a:prstGeom>
-          <a:solidFill>
-            <a:srgbClr val="FFFFFF"/>
-          </a:solidFill>
-          <a:ln/>
-          <a:effectLst>
-            <a:outerShdw blurRad="101600" dist="38100" dir="8100000" algn="bl" rotWithShape="0">
-              <a:srgbClr val="000000">
-                <a:alpha val="18000"/>
-              </a:srgbClr>
-            </a:outerShdw>
-          </a:effectLst>
-        </p:spPr>
-      </p:sp>
-      <p:sp>
-        <p:nvSpPr>
-          <p:cNvPr id="7" name="Shape 5"/>
-          <p:cNvSpPr/>
-          <p:nvPr/>
-        </p:nvSpPr>
-        <p:spPr>
-          <a:xfrm>
-            <a:off x="320040" y="960120"/>
-            <a:ext cx="2011680" cy="502920"/>
-          </a:xfrm>
-          <a:prstGeom prst="rect">
-            <a:avLst/>
-          </a:prstGeom>
-          <a:solidFill>
-            <a:srgbClr val="1B5E20"/>
-          </a:solidFill>
-          <a:ln/>
-        </p:spPr>
-      </p:sp>
-      <p:sp>
-        <p:nvSpPr>
-          <p:cNvPr id="8" name="Text 6"/>
-          <p:cNvSpPr/>
-          <p:nvPr/>
-        </p:nvSpPr>
-        <p:spPr>
-          <a:xfrm>
-            <a:off x="320040" y="960120"/>
-            <a:ext cx="2011680" cy="502920"/>
-          </a:xfrm>
-          <a:prstGeom prst="rect">
-            <a:avLst/>
-          </a:prstGeom>
-          <a:noFill/>
-          <a:ln/>
-        </p:spPr>
-        <p:txBody>
-          <a:bodyPr wrap="square" rtlCol="0" anchor="ctr"/>
-          <a:lstStyle/>
-          <a:p>
-            <a:pPr marL="0" indent="0" algn="ctr">
-              <a:buNone/>
-            </a:pPr>
-            <a:r>
-              <a:rPr lang="en-US" sz="2400" dirty="0">
-                <a:solidFill>
-                  <a:srgbClr val="000000"/>
-                </a:solidFill>
-              </a:rPr>
-              <a:t>👤</a:t>
-            </a:r>
-            <a:endParaRPr lang="en-US" sz="2400" dirty="0"/>
-          </a:p>
-        </p:txBody>
-      </p:sp>
-      <p:sp>
-        <p:nvSpPr>
-          <p:cNvPr id="9" name="Text 7"/>
-          <p:cNvSpPr/>
-          <p:nvPr/>
-        </p:nvSpPr>
-        <p:spPr>
-          <a:xfrm>
-            <a:off x="320040" y="1481328"/>
-            <a:ext cx="2011680" cy="411480"/>
-          </a:xfrm>
-          <a:prstGeom prst="rect">
-            <a:avLst/>
-          </a:prstGeom>
-          <a:noFill/>
-          <a:ln/>
-        </p:spPr>
-        <p:txBody>
-          <a:bodyPr wrap="square" rtlCol="0" anchor="ctr"/>
-          <a:lstStyle/>
-          <a:p>
-            <a:pPr marL="0" indent="0" algn="ctr">
-              <a:buNone/>
-            </a:pPr>
-            <a:r>
-              <a:rPr lang="en-US" sz="1150" b="1" dirty="0">
-                <a:solidFill>
-                  <a:srgbClr val="1B5E20"/>
-                </a:solidFill>
-                <a:latin typeface="Calibri" pitchFamily="34" charset="0"/>
-                <a:ea typeface="Calibri" pitchFamily="34" charset="-122"/>
-                <a:cs typeface="Calibri" pitchFamily="34" charset="-120"/>
-              </a:rPr>
-              <a:t>Manual de Usuario</a:t>
-            </a:r>
-            <a:endParaRPr lang="en-US" sz="1150" dirty="0"/>
-          </a:p>
-        </p:txBody>
-      </p:sp>
-      <p:sp>
-        <p:nvSpPr>
-          <p:cNvPr id="10" name="Text 8"/>
-          <p:cNvSpPr/>
-          <p:nvPr/>
-        </p:nvSpPr>
-        <p:spPr>
-          <a:xfrm>
-            <a:off x="411480" y="1920240"/>
-            <a:ext cx="1828800" cy="1234440"/>
-          </a:xfrm>
-          <a:prstGeom prst="rect">
-            <a:avLst/>
-          </a:prstGeom>
-          <a:noFill/>
-          <a:ln/>
-        </p:spPr>
-        <p:txBody>
-          <a:bodyPr wrap="square" rtlCol="0" anchor="ctr"/>
-          <a:lstStyle/>
-          <a:p>
-            <a:pPr marL="0" indent="0" algn="ctr">
-              <a:buNone/>
-            </a:pPr>
-            <a:r>
-              <a:rPr lang="en-US" sz="1100" dirty="0">
-                <a:solidFill>
-                  <a:srgbClr val="5A5A5A"/>
-                </a:solidFill>
-                <a:latin typeface="Calibri" pitchFamily="34" charset="0"/>
-                <a:ea typeface="Calibri" pitchFamily="34" charset="-122"/>
-                <a:cs typeface="Calibri" pitchFamily="34" charset="-120"/>
-              </a:rPr>
-              <a:t>13 secciones, paso a paso</a:t>
-            </a:r>
-            <a:endParaRPr lang="en-US" sz="1100" dirty="0"/>
-          </a:p>
-          <a:p>
-            <a:pPr marL="0" indent="0" algn="ctr">
-              <a:buNone/>
-            </a:pPr>
-            <a:r>
-              <a:rPr lang="en-US" sz="1100" dirty="0">
-                <a:solidFill>
-                  <a:srgbClr val="5A5A5A"/>
-                </a:solidFill>
-                <a:latin typeface="Calibri" pitchFamily="34" charset="0"/>
-                <a:ea typeface="Calibri" pitchFamily="34" charset="-122"/>
-                <a:cs typeface="Calibri" pitchFamily="34" charset="-120"/>
-              </a:rPr>
-              <a:t>para cada rol de usuario</a:t>
-            </a:r>
-            <a:endParaRPr lang="en-US" sz="1100" dirty="0"/>
-          </a:p>
-        </p:txBody>
-      </p:sp>
-      <p:sp>
-        <p:nvSpPr>
-          <p:cNvPr id="11" name="Shape 9"/>
-          <p:cNvSpPr/>
-          <p:nvPr/>
-        </p:nvSpPr>
-        <p:spPr>
-          <a:xfrm>
-            <a:off x="2468880" y="960120"/>
-            <a:ext cx="2011680" cy="2286000"/>
-          </a:xfrm>
-          <a:prstGeom prst="rect">
-            <a:avLst/>
-          </a:prstGeom>
-          <a:solidFill>
-            <a:srgbClr val="FFFFFF"/>
-          </a:solidFill>
-          <a:ln/>
-          <a:effectLst>
-            <a:outerShdw blurRad="101600" dist="38100" dir="8100000" algn="bl" rotWithShape="0">
-              <a:srgbClr val="000000">
-                <a:alpha val="18000"/>
-              </a:srgbClr>
-            </a:outerShdw>
-          </a:effectLst>
-        </p:spPr>
-      </p:sp>
-      <p:sp>
-        <p:nvSpPr>
-          <p:cNvPr id="12" name="Shape 10"/>
-          <p:cNvSpPr/>
-          <p:nvPr/>
-        </p:nvSpPr>
-        <p:spPr>
-          <a:xfrm>
-            <a:off x="2468880" y="960120"/>
-            <a:ext cx="2011680" cy="502920"/>
-          </a:xfrm>
-          <a:prstGeom prst="rect">
-            <a:avLst/>
-          </a:prstGeom>
-          <a:solidFill>
-            <a:srgbClr val="2E7D32"/>
-          </a:solidFill>
-          <a:ln/>
-        </p:spPr>
-      </p:sp>
-      <p:sp>
-        <p:nvSpPr>
-          <p:cNvPr id="13" name="Text 11"/>
-          <p:cNvSpPr/>
-          <p:nvPr/>
-        </p:nvSpPr>
-        <p:spPr>
-          <a:xfrm>
-            <a:off x="2468880" y="960120"/>
-            <a:ext cx="2011680" cy="502920"/>
-          </a:xfrm>
-          <a:prstGeom prst="rect">
-            <a:avLst/>
-          </a:prstGeom>
-          <a:noFill/>
-          <a:ln/>
-        </p:spPr>
-        <p:txBody>
-          <a:bodyPr wrap="square" rtlCol="0" anchor="ctr"/>
-          <a:lstStyle/>
-          <a:p>
-            <a:pPr marL="0" indent="0" algn="ctr">
-              <a:buNone/>
-            </a:pPr>
-            <a:r>
-              <a:rPr lang="en-US" sz="2400" dirty="0">
-                <a:solidFill>
-                  <a:srgbClr val="000000"/>
-                </a:solidFill>
-              </a:rPr>
-              <a:t>⚙️</a:t>
-            </a:r>
-            <a:endParaRPr lang="en-US" sz="2400" dirty="0"/>
-          </a:p>
-        </p:txBody>
-      </p:sp>
-      <p:sp>
-        <p:nvSpPr>
-          <p:cNvPr id="14" name="Text 12"/>
-          <p:cNvSpPr/>
-          <p:nvPr/>
-        </p:nvSpPr>
-        <p:spPr>
-          <a:xfrm>
-            <a:off x="2468880" y="1481328"/>
-            <a:ext cx="2011680" cy="411480"/>
-          </a:xfrm>
-          <a:prstGeom prst="rect">
-            <a:avLst/>
-          </a:prstGeom>
-          <a:noFill/>
-          <a:ln/>
-        </p:spPr>
-        <p:txBody>
-          <a:bodyPr wrap="square" rtlCol="0" anchor="ctr"/>
-          <a:lstStyle/>
-          <a:p>
-            <a:pPr marL="0" indent="0" algn="ctr">
-              <a:buNone/>
-            </a:pPr>
-            <a:r>
-              <a:rPr lang="en-US" sz="1150" b="1" dirty="0">
-                <a:solidFill>
-                  <a:srgbClr val="1B5E20"/>
-                </a:solidFill>
-                <a:latin typeface="Calibri" pitchFamily="34" charset="0"/>
-                <a:ea typeface="Calibri" pitchFamily="34" charset="-122"/>
-                <a:cs typeface="Calibri" pitchFamily="34" charset="-120"/>
-              </a:rPr>
-              <a:t>Manual Técnico</a:t>
-            </a:r>
-            <a:endParaRPr lang="en-US" sz="1150" dirty="0"/>
-          </a:p>
-        </p:txBody>
-      </p:sp>
-      <p:sp>
-        <p:nvSpPr>
-          <p:cNvPr id="15" name="Text 13"/>
-          <p:cNvSpPr/>
-          <p:nvPr/>
-        </p:nvSpPr>
-        <p:spPr>
-          <a:xfrm>
-            <a:off x="2560320" y="1920240"/>
-            <a:ext cx="1828800" cy="1234440"/>
-          </a:xfrm>
-          <a:prstGeom prst="rect">
-            <a:avLst/>
-          </a:prstGeom>
-          <a:noFill/>
-          <a:ln/>
-        </p:spPr>
-        <p:txBody>
-          <a:bodyPr wrap="square" rtlCol="0" anchor="ctr"/>
-          <a:lstStyle/>
-          <a:p>
-            <a:pPr marL="0" indent="0" algn="ctr">
-              <a:buNone/>
-            </a:pPr>
-            <a:r>
-              <a:rPr lang="en-US" sz="1100" dirty="0">
-                <a:solidFill>
-                  <a:srgbClr val="5A5A5A"/>
-                </a:solidFill>
-                <a:latin typeface="Calibri" pitchFamily="34" charset="0"/>
-                <a:ea typeface="Calibri" pitchFamily="34" charset="-122"/>
-                <a:cs typeface="Calibri" pitchFamily="34" charset="-120"/>
-              </a:rPr>
-              <a:t>Arquitectura, componentes</a:t>
-            </a:r>
-            <a:endParaRPr lang="en-US" sz="1100" dirty="0"/>
-          </a:p>
-          <a:p>
-            <a:pPr marL="0" indent="0" algn="ctr">
-              <a:buNone/>
-            </a:pPr>
-            <a:r>
-              <a:rPr lang="en-US" sz="1100" dirty="0">
-                <a:solidFill>
-                  <a:srgbClr val="5A5A5A"/>
-                </a:solidFill>
-                <a:latin typeface="Calibri" pitchFamily="34" charset="0"/>
-                <a:ea typeface="Calibri" pitchFamily="34" charset="-122"/>
-                <a:cs typeface="Calibri" pitchFamily="34" charset="-120"/>
-              </a:rPr>
-              <a:t>y seguridad del sistema</a:t>
-            </a:r>
-            <a:endParaRPr lang="en-US" sz="1100" dirty="0"/>
-          </a:p>
-        </p:txBody>
-      </p:sp>
-      <p:sp>
-        <p:nvSpPr>
-          <p:cNvPr id="16" name="Shape 14"/>
-          <p:cNvSpPr/>
-          <p:nvPr/>
-        </p:nvSpPr>
-        <p:spPr>
-          <a:xfrm>
-            <a:off x="4617720" y="960120"/>
-            <a:ext cx="2011680" cy="2286000"/>
-          </a:xfrm>
-          <a:prstGeom prst="rect">
-            <a:avLst/>
-          </a:prstGeom>
-          <a:solidFill>
-            <a:srgbClr val="FFFFFF"/>
-          </a:solidFill>
-          <a:ln/>
-          <a:effectLst>
-            <a:outerShdw blurRad="101600" dist="38100" dir="8100000" algn="bl" rotWithShape="0">
-              <a:srgbClr val="000000">
-                <a:alpha val="18000"/>
-              </a:srgbClr>
-            </a:outerShdw>
-          </a:effectLst>
-        </p:spPr>
-      </p:sp>
-      <p:sp>
-        <p:nvSpPr>
-          <p:cNvPr id="17" name="Shape 15"/>
-          <p:cNvSpPr/>
-          <p:nvPr/>
-        </p:nvSpPr>
-        <p:spPr>
-          <a:xfrm>
-            <a:off x="4617720" y="960120"/>
-            <a:ext cx="2011680" cy="502920"/>
-          </a:xfrm>
-          <a:prstGeom prst="rect">
-            <a:avLst/>
-          </a:prstGeom>
-          <a:solidFill>
-            <a:srgbClr val="5D4037"/>
-          </a:solidFill>
-          <a:ln/>
-        </p:spPr>
-      </p:sp>
-      <p:sp>
-        <p:nvSpPr>
-          <p:cNvPr id="18" name="Text 16"/>
-          <p:cNvSpPr/>
-          <p:nvPr/>
-        </p:nvSpPr>
-        <p:spPr>
-          <a:xfrm>
-            <a:off x="4617720" y="960120"/>
-            <a:ext cx="2011680" cy="502920"/>
-          </a:xfrm>
-          <a:prstGeom prst="rect">
-            <a:avLst/>
-          </a:prstGeom>
-          <a:noFill/>
-          <a:ln/>
-        </p:spPr>
-        <p:txBody>
-          <a:bodyPr wrap="square" rtlCol="0" anchor="ctr"/>
-          <a:lstStyle/>
-          <a:p>
-            <a:pPr marL="0" indent="0" algn="ctr">
-              <a:buNone/>
-            </a:pPr>
-            <a:r>
-              <a:rPr lang="en-US" sz="2400" dirty="0">
-                <a:solidFill>
-                  <a:srgbClr val="000000"/>
-                </a:solidFill>
-              </a:rPr>
-              <a:t>☁️</a:t>
-            </a:r>
-            <a:endParaRPr lang="en-US" sz="2400" dirty="0"/>
-          </a:p>
-        </p:txBody>
-      </p:sp>
-      <p:sp>
-        <p:nvSpPr>
-          <p:cNvPr id="19" name="Text 17"/>
-          <p:cNvSpPr/>
-          <p:nvPr/>
-        </p:nvSpPr>
-        <p:spPr>
-          <a:xfrm>
-            <a:off x="4617720" y="1481328"/>
-            <a:ext cx="2011680" cy="411480"/>
-          </a:xfrm>
-          <a:prstGeom prst="rect">
-            <a:avLst/>
-          </a:prstGeom>
-          <a:noFill/>
-          <a:ln/>
-        </p:spPr>
-        <p:txBody>
-          <a:bodyPr wrap="square" rtlCol="0" anchor="ctr"/>
-          <a:lstStyle/>
-          <a:p>
-            <a:pPr marL="0" indent="0" algn="ctr">
-              <a:buNone/>
-            </a:pPr>
-            <a:r>
-              <a:rPr lang="en-US" sz="1150" b="1" dirty="0">
-                <a:solidFill>
-                  <a:srgbClr val="1B5E20"/>
-                </a:solidFill>
-                <a:latin typeface="Calibri" pitchFamily="34" charset="0"/>
-                <a:ea typeface="Calibri" pitchFamily="34" charset="-122"/>
-                <a:cs typeface="Calibri" pitchFamily="34" charset="-120"/>
-              </a:rPr>
-              <a:t>Manual de Despliegue</a:t>
-            </a:r>
-            <a:endParaRPr lang="en-US" sz="1150" dirty="0"/>
-          </a:p>
-        </p:txBody>
-      </p:sp>
-      <p:sp>
-        <p:nvSpPr>
-          <p:cNvPr id="20" name="Text 18"/>
-          <p:cNvSpPr/>
-          <p:nvPr/>
-        </p:nvSpPr>
-        <p:spPr>
-          <a:xfrm>
-            <a:off x="4709160" y="1920240"/>
-            <a:ext cx="1828800" cy="1234440"/>
-          </a:xfrm>
-          <a:prstGeom prst="rect">
-            <a:avLst/>
-          </a:prstGeom>
-          <a:noFill/>
-          <a:ln/>
-        </p:spPr>
-        <p:txBody>
-          <a:bodyPr wrap="square" rtlCol="0" anchor="ctr"/>
-          <a:lstStyle/>
-          <a:p>
-            <a:pPr marL="0" indent="0" algn="ctr">
-              <a:buNone/>
-            </a:pPr>
-            <a:r>
-              <a:rPr lang="en-US" sz="1100" dirty="0">
-                <a:solidFill>
-                  <a:srgbClr val="5A5A5A"/>
-                </a:solidFill>
-                <a:latin typeface="Calibri" pitchFamily="34" charset="0"/>
-                <a:ea typeface="Calibri" pitchFamily="34" charset="-122"/>
-                <a:cs typeface="Calibri" pitchFamily="34" charset="-120"/>
-              </a:rPr>
-              <a:t>Guía completa para</a:t>
-            </a:r>
-            <a:endParaRPr lang="en-US" sz="1100" dirty="0"/>
-          </a:p>
-          <a:p>
-            <a:pPr marL="0" indent="0" algn="ctr">
-              <a:buNone/>
-            </a:pPr>
-            <a:r>
-              <a:rPr lang="en-US" sz="1100" dirty="0">
-                <a:solidFill>
-                  <a:srgbClr val="5A5A5A"/>
-                </a:solidFill>
-                <a:latin typeface="Calibri" pitchFamily="34" charset="0"/>
-                <a:ea typeface="Calibri" pitchFamily="34" charset="-122"/>
-                <a:cs typeface="Calibri" pitchFamily="34" charset="-120"/>
-              </a:rPr>
-              <a:t>Supabase + Vercel</a:t>
-            </a:r>
-            <a:endParaRPr lang="en-US" sz="1100" dirty="0"/>
-          </a:p>
-        </p:txBody>
-      </p:sp>
-      <p:sp>
-        <p:nvSpPr>
-          <p:cNvPr id="21" name="Shape 19"/>
-          <p:cNvSpPr/>
-          <p:nvPr/>
-        </p:nvSpPr>
-        <p:spPr>
-          <a:xfrm>
-            <a:off x="6766560" y="960120"/>
-            <a:ext cx="2011680" cy="2286000"/>
-          </a:xfrm>
-          <a:prstGeom prst="rect">
-            <a:avLst/>
-          </a:prstGeom>
-          <a:solidFill>
-            <a:srgbClr val="FFFFFF"/>
-          </a:solidFill>
-          <a:ln/>
-          <a:effectLst>
-            <a:outerShdw blurRad="101600" dist="38100" dir="8100000" algn="bl" rotWithShape="0">
-              <a:srgbClr val="000000">
-                <a:alpha val="18000"/>
-              </a:srgbClr>
-            </a:outerShdw>
-          </a:effectLst>
-        </p:spPr>
-      </p:sp>
-      <p:sp>
-        <p:nvSpPr>
-          <p:cNvPr id="22" name="Shape 20"/>
-          <p:cNvSpPr/>
-          <p:nvPr/>
-        </p:nvSpPr>
-        <p:spPr>
-          <a:xfrm>
-            <a:off x="6766560" y="960120"/>
-            <a:ext cx="2011680" cy="502920"/>
-          </a:xfrm>
-          <a:prstGeom prst="rect">
-            <a:avLst/>
-          </a:prstGeom>
-          <a:solidFill>
-            <a:srgbClr val="1565C0"/>
-          </a:solidFill>
-          <a:ln/>
-        </p:spPr>
-      </p:sp>
-      <p:sp>
-        <p:nvSpPr>
-          <p:cNvPr id="23" name="Text 21"/>
-          <p:cNvSpPr/>
-          <p:nvPr/>
-        </p:nvSpPr>
-        <p:spPr>
-          <a:xfrm>
-            <a:off x="6766560" y="960120"/>
-            <a:ext cx="2011680" cy="502920"/>
-          </a:xfrm>
-          <a:prstGeom prst="rect">
-            <a:avLst/>
-          </a:prstGeom>
-          <a:noFill/>
-          <a:ln/>
-        </p:spPr>
-        <p:txBody>
-          <a:bodyPr wrap="square" rtlCol="0" anchor="ctr"/>
-          <a:lstStyle/>
-          <a:p>
-            <a:pPr marL="0" indent="0" algn="ctr">
-              <a:buNone/>
-            </a:pPr>
-            <a:r>
-              <a:rPr lang="en-US" sz="2400" dirty="0">
-                <a:solidFill>
-                  <a:srgbClr val="000000"/>
-                </a:solidFill>
-              </a:rPr>
-              <a:t>📋</a:t>
-            </a:r>
-            <a:endParaRPr lang="en-US" sz="2400" dirty="0"/>
-          </a:p>
-        </p:txBody>
-      </p:sp>
-      <p:sp>
-        <p:nvSpPr>
-          <p:cNvPr id="24" name="Text 22"/>
-          <p:cNvSpPr/>
-          <p:nvPr/>
-        </p:nvSpPr>
-        <p:spPr>
-          <a:xfrm>
-            <a:off x="6766560" y="1481328"/>
-            <a:ext cx="2011680" cy="411480"/>
-          </a:xfrm>
-          <a:prstGeom prst="rect">
-            <a:avLst/>
-          </a:prstGeom>
-          <a:noFill/>
-          <a:ln/>
-        </p:spPr>
-        <p:txBody>
-          <a:bodyPr wrap="square" rtlCol="0" anchor="ctr"/>
-          <a:lstStyle/>
-          <a:p>
-            <a:pPr marL="0" indent="0" algn="ctr">
-              <a:buNone/>
-            </a:pPr>
-            <a:r>
-              <a:rPr lang="en-US" sz="1150" b="1" dirty="0">
-                <a:solidFill>
-                  <a:srgbClr val="1B5E20"/>
-                </a:solidFill>
-                <a:latin typeface="Calibri" pitchFamily="34" charset="0"/>
-                <a:ea typeface="Calibri" pitchFamily="34" charset="-122"/>
-                <a:cs typeface="Calibri" pitchFamily="34" charset="-120"/>
-              </a:rPr>
-              <a:t>Manual del Proyecto</a:t>
-            </a:r>
-            <a:endParaRPr lang="en-US" sz="1150" dirty="0"/>
-          </a:p>
-        </p:txBody>
-      </p:sp>
-      <p:sp>
-        <p:nvSpPr>
-          <p:cNvPr id="25" name="Text 23"/>
-          <p:cNvSpPr/>
-          <p:nvPr/>
-        </p:nvSpPr>
-        <p:spPr>
-          <a:xfrm>
-            <a:off x="6858000" y="1920240"/>
-            <a:ext cx="1828800" cy="1234440"/>
-          </a:xfrm>
-          <a:prstGeom prst="rect">
-            <a:avLst/>
-          </a:prstGeom>
-          <a:noFill/>
-          <a:ln/>
-        </p:spPr>
-        <p:txBody>
-          <a:bodyPr wrap="square" rtlCol="0" anchor="ctr"/>
-          <a:lstStyle/>
-          <a:p>
-            <a:pPr marL="0" indent="0" algn="ctr">
-              <a:buNone/>
-            </a:pPr>
-            <a:r>
-              <a:rPr lang="en-US" sz="1100" dirty="0">
-                <a:solidFill>
-                  <a:srgbClr val="5A5A5A"/>
-                </a:solidFill>
-                <a:latin typeface="Calibri" pitchFamily="34" charset="0"/>
-                <a:ea typeface="Calibri" pitchFamily="34" charset="-122"/>
-                <a:cs typeface="Calibri" pitchFamily="34" charset="-120"/>
-              </a:rPr>
-              <a:t>Planificación, metodología</a:t>
-            </a:r>
-            <a:endParaRPr lang="en-US" sz="1100" dirty="0"/>
-          </a:p>
-          <a:p>
-            <a:pPr marL="0" indent="0" algn="ctr">
-              <a:buNone/>
-            </a:pPr>
-            <a:r>
-              <a:rPr lang="en-US" sz="1100" dirty="0">
-                <a:solidFill>
-                  <a:srgbClr val="5A5A5A"/>
-                </a:solidFill>
-                <a:latin typeface="Calibri" pitchFamily="34" charset="0"/>
-                <a:ea typeface="Calibri" pitchFamily="34" charset="-122"/>
-                <a:cs typeface="Calibri" pitchFamily="34" charset="-120"/>
-              </a:rPr>
-              <a:t>y cronograma</a:t>
-            </a:r>
-            <a:endParaRPr lang="en-US" sz="1100" dirty="0"/>
-          </a:p>
-        </p:txBody>
-      </p:sp>
-      <p:sp>
-        <p:nvSpPr>
-          <p:cNvPr id="26" name="Shape 24"/>
-          <p:cNvSpPr/>
-          <p:nvPr/>
-        </p:nvSpPr>
-        <p:spPr>
-          <a:xfrm>
-            <a:off x="320040" y="3401568"/>
-            <a:ext cx="8503920" cy="320040"/>
-          </a:xfrm>
-          <a:prstGeom prst="rect">
-            <a:avLst/>
-          </a:prstGeom>
-          <a:solidFill>
-            <a:srgbClr val="1B5E20"/>
-          </a:solidFill>
-          <a:ln/>
-        </p:spPr>
-      </p:sp>
-      <p:sp>
-        <p:nvSpPr>
-          <p:cNvPr id="27" name="Text 25"/>
-          <p:cNvSpPr/>
-          <p:nvPr/>
-        </p:nvSpPr>
-        <p:spPr>
-          <a:xfrm>
-            <a:off x="320040" y="3401568"/>
-            <a:ext cx="8503920" cy="320040"/>
-          </a:xfrm>
-          <a:prstGeom prst="rect">
-            <a:avLst/>
-          </a:prstGeom>
-          <a:noFill/>
-          <a:ln/>
-        </p:spPr>
-        <p:txBody>
-          <a:bodyPr wrap="square" rtlCol="0" anchor="ctr"/>
-          <a:lstStyle/>
-          <a:p>
-            <a:pPr marL="0" indent="0" algn="ctr">
-              <a:buNone/>
-            </a:pPr>
-            <a:r>
-              <a:rPr lang="en-US" sz="1300" b="1" dirty="0">
-                <a:solidFill>
-                  <a:srgbClr val="FFFFFF"/>
-                </a:solidFill>
-                <a:latin typeface="Calibri" pitchFamily="34" charset="0"/>
-                <a:ea typeface="Calibri" pitchFamily="34" charset="-122"/>
-                <a:cs typeface="Calibri" pitchFamily="34" charset="-120"/>
-              </a:rPr>
-              <a:t>📐  Diagramas Técnicos</a:t>
-            </a:r>
-            <a:endParaRPr lang="en-US" sz="1300" dirty="0"/>
-          </a:p>
-        </p:txBody>
-      </p:sp>
-      <p:sp>
-        <p:nvSpPr>
-          <p:cNvPr id="28" name="Shape 26"/>
-          <p:cNvSpPr/>
-          <p:nvPr/>
-        </p:nvSpPr>
-        <p:spPr>
-          <a:xfrm>
-            <a:off x="457200" y="3785616"/>
-            <a:ext cx="2606040" cy="1024128"/>
-          </a:xfrm>
-          <a:prstGeom prst="rect">
-            <a:avLst/>
-          </a:prstGeom>
-          <a:solidFill>
-            <a:srgbClr val="FFFFFF"/>
-          </a:solidFill>
-          <a:ln/>
-          <a:effectLst>
-            <a:outerShdw blurRad="63500" dist="25400" dir="8100000" algn="bl" rotWithShape="0">
-              <a:srgbClr val="000000">
-                <a:alpha val="10000"/>
-              </a:srgbClr>
-            </a:outerShdw>
-          </a:effectLst>
-        </p:spPr>
-      </p:sp>
-      <p:sp>
-        <p:nvSpPr>
-          <p:cNvPr id="29" name="Text 27"/>
-          <p:cNvSpPr/>
-          <p:nvPr/>
-        </p:nvSpPr>
-        <p:spPr>
-          <a:xfrm>
-            <a:off x="457200" y="3785616"/>
-            <a:ext cx="594360" cy="1024128"/>
-          </a:xfrm>
-          <a:prstGeom prst="rect">
-            <a:avLst/>
-          </a:prstGeom>
-          <a:noFill/>
-          <a:ln/>
-        </p:spPr>
-        <p:txBody>
-          <a:bodyPr wrap="square" rtlCol="0" anchor="ctr"/>
-          <a:lstStyle/>
-          <a:p>
-            <a:pPr marL="0" indent="0" algn="ctr">
-              <a:buNone/>
-            </a:pPr>
-            <a:r>
-              <a:rPr lang="en-US" sz="2400" dirty="0">
-                <a:solidFill>
-                  <a:srgbClr val="000000"/>
-                </a:solidFill>
-              </a:rPr>
-              <a:t>🏗️</a:t>
-            </a:r>
-            <a:endParaRPr lang="en-US" sz="2400" dirty="0"/>
-          </a:p>
-        </p:txBody>
-      </p:sp>
-      <p:sp>
-        <p:nvSpPr>
-          <p:cNvPr id="30" name="Text 28"/>
-          <p:cNvSpPr/>
-          <p:nvPr/>
-        </p:nvSpPr>
-        <p:spPr>
-          <a:xfrm>
-            <a:off x="1078992" y="3785616"/>
-            <a:ext cx="1920240" cy="475488"/>
-          </a:xfrm>
-          <a:prstGeom prst="rect">
-            <a:avLst/>
-          </a:prstGeom>
-          <a:noFill/>
-          <a:ln/>
-        </p:spPr>
-        <p:txBody>
-          <a:bodyPr wrap="square" rtlCol="0" anchor="ctr"/>
-          <a:lstStyle/>
-          <a:p>
-            <a:pPr marL="0" indent="0">
-              <a:buNone/>
-            </a:pPr>
-            <a:r>
-              <a:rPr lang="en-US" sz="1200" b="1" dirty="0">
-                <a:solidFill>
-                  <a:srgbClr val="1B5E20"/>
-                </a:solidFill>
-                <a:latin typeface="Calibri" pitchFamily="34" charset="0"/>
-                <a:ea typeface="Calibri" pitchFamily="34" charset="-122"/>
-                <a:cs typeface="Calibri" pitchFamily="34" charset="-120"/>
-              </a:rPr>
-              <a:t>Diagrama de Clases</a:t>
-            </a:r>
-            <a:endParaRPr lang="en-US" sz="1200" dirty="0"/>
-          </a:p>
-        </p:txBody>
-      </p:sp>
-      <p:sp>
-        <p:nvSpPr>
-          <p:cNvPr id="31" name="Text 29"/>
-          <p:cNvSpPr/>
-          <p:nvPr/>
-        </p:nvSpPr>
-        <p:spPr>
-          <a:xfrm>
-            <a:off x="1078992" y="4251960"/>
-            <a:ext cx="1920240" cy="457200"/>
-          </a:xfrm>
-          <a:prstGeom prst="rect">
-            <a:avLst/>
-          </a:prstGeom>
-          <a:noFill/>
-          <a:ln/>
-        </p:spPr>
-        <p:txBody>
-          <a:bodyPr wrap="square" rtlCol="0" anchor="t"/>
-          <a:lstStyle/>
-          <a:p>
-            <a:pPr marL="0" indent="0">
-              <a:buNone/>
-            </a:pPr>
-            <a:r>
-              <a:rPr lang="en-US" sz="1050" dirty="0">
-                <a:solidFill>
-                  <a:srgbClr val="5A5A5A"/>
-                </a:solidFill>
-                <a:latin typeface="Calibri" pitchFamily="34" charset="0"/>
-                <a:ea typeface="Calibri" pitchFamily="34" charset="-122"/>
-                <a:cs typeface="Calibri" pitchFamily="34" charset="-120"/>
-              </a:rPr>
-              <a:t>Estructura de entidades y relaciones</a:t>
-            </a:r>
-            <a:endParaRPr lang="en-US" sz="1050" dirty="0"/>
-          </a:p>
-        </p:txBody>
-      </p:sp>
-      <p:sp>
-        <p:nvSpPr>
-          <p:cNvPr id="32" name="Shape 30"/>
-          <p:cNvSpPr/>
-          <p:nvPr/>
-        </p:nvSpPr>
-        <p:spPr>
-          <a:xfrm>
-            <a:off x="3291840" y="3785616"/>
-            <a:ext cx="2606040" cy="1024128"/>
-          </a:xfrm>
-          <a:prstGeom prst="rect">
-            <a:avLst/>
-          </a:prstGeom>
-          <a:solidFill>
-            <a:srgbClr val="FFFFFF"/>
-          </a:solidFill>
-          <a:ln/>
-          <a:effectLst>
-            <a:outerShdw blurRad="63500" dist="25400" dir="8100000" algn="bl" rotWithShape="0">
-              <a:srgbClr val="000000">
-                <a:alpha val="10000"/>
-              </a:srgbClr>
-            </a:outerShdw>
-          </a:effectLst>
-        </p:spPr>
-      </p:sp>
-      <p:sp>
-        <p:nvSpPr>
-          <p:cNvPr id="33" name="Text 31"/>
-          <p:cNvSpPr/>
-          <p:nvPr/>
-        </p:nvSpPr>
-        <p:spPr>
-          <a:xfrm>
-            <a:off x="3291840" y="3785616"/>
-            <a:ext cx="594360" cy="1024128"/>
-          </a:xfrm>
-          <a:prstGeom prst="rect">
-            <a:avLst/>
-          </a:prstGeom>
-          <a:noFill/>
-          <a:ln/>
-        </p:spPr>
-        <p:txBody>
-          <a:bodyPr wrap="square" rtlCol="0" anchor="ctr"/>
-          <a:lstStyle/>
-          <a:p>
-            <a:pPr marL="0" indent="0" algn="ctr">
-              <a:buNone/>
-            </a:pPr>
-            <a:r>
-              <a:rPr lang="en-US" sz="2400" dirty="0">
-                <a:solidFill>
-                  <a:srgbClr val="000000"/>
-                </a:solidFill>
-              </a:rPr>
-              <a:t>🔄</a:t>
-            </a:r>
-            <a:endParaRPr lang="en-US" sz="2400" dirty="0"/>
-          </a:p>
-        </p:txBody>
-      </p:sp>
-      <p:sp>
-        <p:nvSpPr>
-          <p:cNvPr id="34" name="Text 32"/>
-          <p:cNvSpPr/>
-          <p:nvPr/>
-        </p:nvSpPr>
-        <p:spPr>
-          <a:xfrm>
-            <a:off x="3913632" y="3785616"/>
-            <a:ext cx="1920240" cy="475488"/>
-          </a:xfrm>
-          <a:prstGeom prst="rect">
-            <a:avLst/>
-          </a:prstGeom>
-          <a:noFill/>
-          <a:ln/>
-        </p:spPr>
-        <p:txBody>
-          <a:bodyPr wrap="square" rtlCol="0" anchor="ctr"/>
-          <a:lstStyle/>
-          <a:p>
-            <a:pPr marL="0" indent="0">
-              <a:buNone/>
-            </a:pPr>
-            <a:r>
-              <a:rPr lang="en-US" sz="1200" b="1" dirty="0">
-                <a:solidFill>
-                  <a:srgbClr val="1B5E20"/>
-                </a:solidFill>
-                <a:latin typeface="Calibri" pitchFamily="34" charset="0"/>
-                <a:ea typeface="Calibri" pitchFamily="34" charset="-122"/>
-                <a:cs typeface="Calibri" pitchFamily="34" charset="-120"/>
-              </a:rPr>
-              <a:t>Diagrama de Flujo</a:t>
-            </a:r>
-            <a:endParaRPr lang="en-US" sz="1200" dirty="0"/>
-          </a:p>
-        </p:txBody>
-      </p:sp>
-      <p:sp>
-        <p:nvSpPr>
-          <p:cNvPr id="35" name="Text 33"/>
-          <p:cNvSpPr/>
-          <p:nvPr/>
-        </p:nvSpPr>
-        <p:spPr>
-          <a:xfrm>
-            <a:off x="3913632" y="4251960"/>
-            <a:ext cx="1920240" cy="457200"/>
-          </a:xfrm>
-          <a:prstGeom prst="rect">
-            <a:avLst/>
-          </a:prstGeom>
-          <a:noFill/>
-          <a:ln/>
-        </p:spPr>
-        <p:txBody>
-          <a:bodyPr wrap="square" rtlCol="0" anchor="t"/>
-          <a:lstStyle/>
-          <a:p>
-            <a:pPr marL="0" indent="0">
-              <a:buNone/>
-            </a:pPr>
-            <a:r>
-              <a:rPr lang="en-US" sz="1050" dirty="0">
-                <a:solidFill>
-                  <a:srgbClr val="5A5A5A"/>
-                </a:solidFill>
-                <a:latin typeface="Calibri" pitchFamily="34" charset="0"/>
-                <a:ea typeface="Calibri" pitchFamily="34" charset="-122"/>
-                <a:cs typeface="Calibri" pitchFamily="34" charset="-120"/>
-              </a:rPr>
-              <a:t>Procesos y decisiones del sistema</a:t>
-            </a:r>
-            <a:endParaRPr lang="en-US" sz="1050" dirty="0"/>
-          </a:p>
-        </p:txBody>
-      </p:sp>
-      <p:sp>
-        <p:nvSpPr>
-          <p:cNvPr id="36" name="Shape 34"/>
-          <p:cNvSpPr/>
-          <p:nvPr/>
-        </p:nvSpPr>
-        <p:spPr>
-          <a:xfrm>
-            <a:off x="6126480" y="3785616"/>
-            <a:ext cx="2606040" cy="1024128"/>
-          </a:xfrm>
-          <a:prstGeom prst="rect">
-            <a:avLst/>
-          </a:prstGeom>
-          <a:solidFill>
-            <a:srgbClr val="FFFFFF"/>
-          </a:solidFill>
-          <a:ln/>
-          <a:effectLst>
-            <a:outerShdw blurRad="63500" dist="25400" dir="8100000" algn="bl" rotWithShape="0">
-              <a:srgbClr val="000000">
-                <a:alpha val="10000"/>
-              </a:srgbClr>
-            </a:outerShdw>
-          </a:effectLst>
-        </p:spPr>
-      </p:sp>
-      <p:sp>
-        <p:nvSpPr>
-          <p:cNvPr id="37" name="Text 35"/>
-          <p:cNvSpPr/>
-          <p:nvPr/>
-        </p:nvSpPr>
-        <p:spPr>
-          <a:xfrm>
-            <a:off x="6126480" y="3785616"/>
-            <a:ext cx="594360" cy="1024128"/>
-          </a:xfrm>
-          <a:prstGeom prst="rect">
-            <a:avLst/>
-          </a:prstGeom>
-          <a:noFill/>
-          <a:ln/>
-        </p:spPr>
-        <p:txBody>
-          <a:bodyPr wrap="square" rtlCol="0" anchor="ctr"/>
-          <a:lstStyle/>
-          <a:p>
-            <a:pPr marL="0" indent="0" algn="ctr">
-              <a:buNone/>
-            </a:pPr>
-            <a:r>
-              <a:rPr lang="en-US" sz="2400" dirty="0">
-                <a:solidFill>
-                  <a:srgbClr val="000000"/>
-                </a:solidFill>
-              </a:rPr>
-              <a:t>🗃️</a:t>
-            </a:r>
-            <a:endParaRPr lang="en-US" sz="2400" dirty="0"/>
-          </a:p>
-        </p:txBody>
-      </p:sp>
-      <p:sp>
-        <p:nvSpPr>
-          <p:cNvPr id="38" name="Text 36"/>
-          <p:cNvSpPr/>
-          <p:nvPr/>
-        </p:nvSpPr>
-        <p:spPr>
-          <a:xfrm>
-            <a:off x="6748272" y="3785616"/>
-            <a:ext cx="1920240" cy="475488"/>
-          </a:xfrm>
-          <a:prstGeom prst="rect">
-            <a:avLst/>
-          </a:prstGeom>
-          <a:noFill/>
-          <a:ln/>
-        </p:spPr>
-        <p:txBody>
-          <a:bodyPr wrap="square" rtlCol="0" anchor="ctr"/>
-          <a:lstStyle/>
-          <a:p>
-            <a:pPr marL="0" indent="0">
-              <a:buNone/>
-            </a:pPr>
-            <a:r>
-              <a:rPr lang="en-US" sz="1200" b="1" dirty="0">
-                <a:solidFill>
-                  <a:srgbClr val="1B5E20"/>
-                </a:solidFill>
-                <a:latin typeface="Calibri" pitchFamily="34" charset="0"/>
-                <a:ea typeface="Calibri" pitchFamily="34" charset="-122"/>
-                <a:cs typeface="Calibri" pitchFamily="34" charset="-120"/>
-              </a:rPr>
-              <a:t>Modelo Relacional</a:t>
-            </a:r>
-            <a:endParaRPr lang="en-US" sz="1200" dirty="0"/>
-          </a:p>
-        </p:txBody>
-      </p:sp>
-      <p:sp>
-        <p:nvSpPr>
-          <p:cNvPr id="39" name="Text 37"/>
-          <p:cNvSpPr/>
-          <p:nvPr/>
-        </p:nvSpPr>
-        <p:spPr>
-          <a:xfrm>
-            <a:off x="6748272" y="4251960"/>
-            <a:ext cx="1920240" cy="457200"/>
-          </a:xfrm>
-          <a:prstGeom prst="rect">
-            <a:avLst/>
-          </a:prstGeom>
-          <a:noFill/>
-          <a:ln/>
-        </p:spPr>
-        <p:txBody>
-          <a:bodyPr wrap="square" rtlCol="0" anchor="t"/>
-          <a:lstStyle/>
-          <a:p>
-            <a:pPr marL="0" indent="0">
-              <a:buNone/>
-            </a:pPr>
-            <a:r>
-              <a:rPr lang="en-US" sz="1050" dirty="0">
-                <a:solidFill>
-                  <a:srgbClr val="5A5A5A"/>
-                </a:solidFill>
-                <a:latin typeface="Calibri" pitchFamily="34" charset="0"/>
-                <a:ea typeface="Calibri" pitchFamily="34" charset="-122"/>
-                <a:cs typeface="Calibri" pitchFamily="34" charset="-120"/>
-              </a:rPr>
-              <a:t>Tablas, claves y relaciones DB</a:t>
-            </a:r>
-            <a:endParaRPr lang="en-US" sz="1050" dirty="0"/>
-          </a:p>
-        </p:txBody>
-      </p:sp>
-    </p:spTree>
-  </p:cSld>
-  <p:clrMapOvr>
-    <a:masterClrMapping/>
-  </p:clrMapOvr>
-</p:sld>
-</file>
-
-<file path=ppt/slides/slide16.xml><?xml version="1.0" encoding="utf-8"?>
 <p:sld xmlns:a="http://schemas.openxmlformats.org/drawingml/2006/main" xmlns:r="http://schemas.openxmlformats.org/officeDocument/2006/relationships" xmlns:p="http://schemas.openxmlformats.org/presentationml/2006/main">
   <p:cSld name="Slide 16">
     <p:bg>
@@ -9236,7 +6810,7 @@
                 <a:ea typeface="Calibri" pitchFamily="34" charset="-122"/>
                 <a:cs typeface="Calibri" pitchFamily="34" charset="-120"/>
               </a:rPr>
-              <a:t>16 / 18</a:t>
+              <a:t>14 / 16</a:t>
             </a:r>
             <a:endParaRPr lang="en-US" sz="900" dirty="0"/>
           </a:p>
@@ -10546,7 +8120,7 @@
 </p:sld>
 </file>
 
-<file path=ppt/slides/slide17.xml><?xml version="1.0" encoding="utf-8"?>
+<file path=ppt/slides/slide15.xml><?xml version="1.0" encoding="utf-8"?>
 <p:sld xmlns:a="http://schemas.openxmlformats.org/drawingml/2006/main" xmlns:r="http://schemas.openxmlformats.org/officeDocument/2006/relationships" xmlns:p="http://schemas.openxmlformats.org/presentationml/2006/main">
   <p:cSld name="Slide 17">
     <p:bg>
@@ -10702,7 +8276,7 @@
                 <a:ea typeface="Calibri" pitchFamily="34" charset="-122"/>
                 <a:cs typeface="Calibri" pitchFamily="34" charset="-120"/>
               </a:rPr>
-              <a:t>17 / 18</a:t>
+              <a:t>15 / 16</a:t>
             </a:r>
             <a:endParaRPr lang="en-US" sz="900" dirty="0"/>
           </a:p>
@@ -11836,7 +9410,7 @@
 </p:sld>
 </file>
 
-<file path=ppt/slides/slide18.xml><?xml version="1.0" encoding="utf-8"?>
+<file path=ppt/slides/slide16.xml><?xml version="1.0" encoding="utf-8"?>
 <p:sld xmlns:a="http://schemas.openxmlformats.org/drawingml/2006/main" xmlns:r="http://schemas.openxmlformats.org/officeDocument/2006/relationships" xmlns:p="http://schemas.openxmlformats.org/presentationml/2006/main">
   <p:cSld name="Slide 18">
     <p:spTree>
@@ -11971,7 +9545,7 @@
                 <a:ea typeface="Calibri" pitchFamily="34" charset="-122"/>
                 <a:cs typeface="Calibri" pitchFamily="34" charset="-120"/>
               </a:rPr>
-              <a:t>18 / 18</a:t>
+              <a:t>16 / 16</a:t>
             </a:r>
             <a:endParaRPr lang="en-US" sz="900" dirty="0"/>
           </a:p>
@@ -12588,7 +10162,7 @@
                 <a:ea typeface="Calibri" pitchFamily="34" charset="-122"/>
                 <a:cs typeface="Calibri" pitchFamily="34" charset="-120"/>
               </a:rPr>
-              <a:t>2 / 18</a:t>
+              <a:t>2 / 16</a:t>
             </a:r>
             <a:endParaRPr lang="en-US" sz="900" dirty="0"/>
           </a:p>
@@ -13701,11 +11275,8 @@
           <a:bodyPr wrap="square" rtlCol="0" anchor="ctr"/>
           <a:lstStyle/>
           <a:p>
-            <a:pPr marL="0" indent="0">
-              <a:buNone/>
-            </a:pPr>
-            <a:r>
-              <a:rPr lang="en-US" sz="1300" dirty="0">
+            <a:r>
+              <a:rPr lang="es-ES" sz="1300" noProof="0" dirty="0">
                 <a:solidFill>
                   <a:srgbClr val="FFFFFF"/>
                 </a:solidFill>
@@ -13713,95 +11284,9 @@
                 <a:ea typeface="Calibri" pitchFamily="34" charset="-122"/>
                 <a:cs typeface="Calibri" pitchFamily="34" charset="-120"/>
               </a:rPr>
-              <a:t>Metodología y Documentación</a:t>
-            </a:r>
-            <a:endParaRPr lang="en-US" sz="1300" dirty="0"/>
-          </a:p>
-        </p:txBody>
-      </p:sp>
-      <p:sp>
-        <p:nvSpPr>
-          <p:cNvPr id="42" name="Shape 40"/>
-          <p:cNvSpPr/>
-          <p:nvPr/>
-        </p:nvSpPr>
-        <p:spPr>
-          <a:xfrm>
-            <a:off x="4846320" y="3995928"/>
-            <a:ext cx="4114800" cy="621792"/>
-          </a:xfrm>
-          <a:prstGeom prst="rect">
-            <a:avLst/>
-          </a:prstGeom>
-          <a:solidFill>
-            <a:srgbClr val="1B5E20"/>
-          </a:solidFill>
-          <a:ln/>
-          <a:effectLst>
-            <a:outerShdw blurRad="63500" dist="25400" dir="8100000" algn="bl" rotWithShape="0">
-              <a:srgbClr val="000000">
-                <a:alpha val="10000"/>
-              </a:srgbClr>
-            </a:outerShdw>
-          </a:effectLst>
-        </p:spPr>
-      </p:sp>
-      <p:sp>
-        <p:nvSpPr>
-          <p:cNvPr id="43" name="Shape 41"/>
-          <p:cNvSpPr/>
-          <p:nvPr/>
-        </p:nvSpPr>
-        <p:spPr>
-          <a:xfrm>
-            <a:off x="4846320" y="3995928"/>
-            <a:ext cx="502920" cy="621792"/>
-          </a:xfrm>
-          <a:prstGeom prst="rect">
-            <a:avLst/>
-          </a:prstGeom>
-          <a:solidFill>
-            <a:srgbClr val="D4A017"/>
-          </a:solidFill>
-          <a:ln/>
-        </p:spPr>
-      </p:sp>
-      <p:sp>
-        <p:nvSpPr>
-          <p:cNvPr id="44" name="Text 42"/>
-          <p:cNvSpPr/>
-          <p:nvPr/>
-        </p:nvSpPr>
-        <p:spPr>
-          <a:xfrm>
-            <a:off x="4846320" y="3995928"/>
-            <a:ext cx="502920" cy="621792"/>
-          </a:xfrm>
-          <a:prstGeom prst="rect">
-            <a:avLst/>
-          </a:prstGeom>
-          <a:noFill/>
-          <a:ln/>
-        </p:spPr>
-        <p:txBody>
-          <a:bodyPr wrap="square" rtlCol="0" anchor="ctr"/>
-          <a:lstStyle/>
-          <a:p>
-            <a:pPr marL="0" indent="0" algn="ctr">
-              <a:buNone/>
-            </a:pPr>
-            <a:r>
-              <a:rPr lang="en-US" sz="1600" b="1" dirty="0">
-                <a:solidFill>
-                  <a:srgbClr val="1B5E20"/>
-                </a:solidFill>
-                <a:latin typeface="Calibri" pitchFamily="34" charset="0"/>
-                <a:ea typeface="Calibri" pitchFamily="34" charset="-122"/>
-                <a:cs typeface="Calibri" pitchFamily="34" charset="-120"/>
-              </a:rPr>
-              <a:t>10</a:t>
-            </a:r>
-            <a:endParaRPr lang="en-US" sz="1600" dirty="0"/>
+              <a:t>Cifras y Conclusiones</a:t>
+            </a:r>
+            <a:endParaRPr lang="es-ES" sz="1300" noProof="0" dirty="0"/>
           </a:p>
         </p:txBody>
       </p:sp>
@@ -13829,17 +11314,6 @@
             <a:pPr marL="0" indent="0">
               <a:buNone/>
             </a:pPr>
-            <a:r>
-              <a:rPr lang="en-US" sz="1300" dirty="0">
-                <a:solidFill>
-                  <a:srgbClr val="FFFFFF"/>
-                </a:solidFill>
-                <a:latin typeface="Calibri" pitchFamily="34" charset="0"/>
-                <a:ea typeface="Calibri" pitchFamily="34" charset="-122"/>
-                <a:cs typeface="Calibri" pitchFamily="34" charset="-120"/>
-              </a:rPr>
-              <a:t>Cifras y Conclusiones</a:t>
-            </a:r>
             <a:endParaRPr lang="en-US" sz="1300" dirty="0"/>
           </a:p>
         </p:txBody>
@@ -14008,7 +11482,7 @@
                 <a:ea typeface="Calibri" pitchFamily="34" charset="-122"/>
                 <a:cs typeface="Calibri" pitchFamily="34" charset="-120"/>
               </a:rPr>
-              <a:t>3 / 18</a:t>
+              <a:t>3 / 16</a:t>
             </a:r>
             <a:endParaRPr lang="en-US" sz="900" dirty="0"/>
           </a:p>
@@ -14716,7 +12190,7 @@
                 <a:ea typeface="Calibri" pitchFamily="34" charset="-122"/>
                 <a:cs typeface="Calibri" pitchFamily="34" charset="-120"/>
               </a:rPr>
-              <a:t>4 / 18</a:t>
+              <a:t>4 / 16</a:t>
             </a:r>
             <a:endParaRPr lang="en-US" sz="900" dirty="0"/>
           </a:p>
@@ -15862,7 +13336,7 @@
                 <a:ea typeface="Calibri" pitchFamily="34" charset="-122"/>
                 <a:cs typeface="Calibri" pitchFamily="34" charset="-120"/>
               </a:rPr>
-              <a:t>5 / 18</a:t>
+              <a:t>5 / 16</a:t>
             </a:r>
             <a:endParaRPr lang="en-US" sz="900" dirty="0"/>
           </a:p>
@@ -17135,7 +14609,7 @@
                 <a:ea typeface="Calibri" pitchFamily="34" charset="-122"/>
                 <a:cs typeface="Calibri" pitchFamily="34" charset="-120"/>
               </a:rPr>
-              <a:t>6 / 18</a:t>
+              <a:t>6 / 16</a:t>
             </a:r>
             <a:endParaRPr lang="en-US" sz="900" dirty="0"/>
           </a:p>
@@ -18220,7 +15694,7 @@
                 <a:ea typeface="Calibri" pitchFamily="34" charset="-122"/>
                 <a:cs typeface="Calibri" pitchFamily="34" charset="-120"/>
               </a:rPr>
-              <a:t>7 / 18</a:t>
+              <a:t>7 / 16</a:t>
             </a:r>
             <a:endParaRPr lang="en-US" sz="900" dirty="0"/>
           </a:p>
@@ -20325,7 +17799,7 @@
                 <a:ea typeface="Calibri" pitchFamily="34" charset="-122"/>
                 <a:cs typeface="Calibri" pitchFamily="34" charset="-120"/>
               </a:rPr>
-              <a:t>8 / 18</a:t>
+              <a:t>8 / 16</a:t>
             </a:r>
             <a:endParaRPr lang="en-US" sz="900" dirty="0"/>
           </a:p>
@@ -21985,7 +19459,7 @@
                 <a:ea typeface="Calibri" pitchFamily="34" charset="-122"/>
                 <a:cs typeface="Calibri" pitchFamily="34" charset="-120"/>
               </a:rPr>
-              <a:t>9 / 18</a:t>
+              <a:t>9 / 16</a:t>
             </a:r>
             <a:endParaRPr lang="es-ES" sz="900" noProof="0" dirty="0"/>
           </a:p>

</xml_diff>